<commit_message>
modifies website to mobile
</commit_message>
<xml_diff>
--- a/logos/logos.pptx
+++ b/logos/logos.pptx
@@ -9598,7 +9598,18 @@
           <p:nvPr/>
         </p:nvPicPr>
         <p:blipFill>
-          <a:blip r:embed="rId2"/>
+          <a:blip r:embed="rId2">
+            <a:clrChange>
+              <a:clrFrom>
+                <a:srgbClr val="FFFFFF"/>
+              </a:clrFrom>
+              <a:clrTo>
+                <a:srgbClr val="FFFFFF">
+                  <a:alpha val="0"/>
+                </a:srgbClr>
+              </a:clrTo>
+            </a:clrChange>
+          </a:blip>
           <a:stretch>
             <a:fillRect/>
           </a:stretch>
@@ -9628,14 +9639,25 @@
           <p:nvPr/>
         </p:nvPicPr>
         <p:blipFill>
-          <a:blip r:embed="rId3"/>
+          <a:blip r:embed="rId3">
+            <a:clrChange>
+              <a:clrFrom>
+                <a:srgbClr val="FFFFFF"/>
+              </a:clrFrom>
+              <a:clrTo>
+                <a:srgbClr val="FFFFFF">
+                  <a:alpha val="0"/>
+                </a:srgbClr>
+              </a:clrTo>
+            </a:clrChange>
+          </a:blip>
           <a:stretch>
             <a:fillRect/>
           </a:stretch>
         </p:blipFill>
         <p:spPr>
           <a:xfrm>
-            <a:off x="8529442" y="5989753"/>
+            <a:off x="-7320158" y="10866553"/>
             <a:ext cx="5092700" cy="5118100"/>
           </a:xfrm>
           <a:prstGeom prst="rect">
@@ -9658,14 +9680,25 @@
           <p:nvPr/>
         </p:nvPicPr>
         <p:blipFill>
-          <a:blip r:embed="rId4"/>
+          <a:blip r:embed="rId4">
+            <a:clrChange>
+              <a:clrFrom>
+                <a:srgbClr val="FFFFFF"/>
+              </a:clrFrom>
+              <a:clrTo>
+                <a:srgbClr val="FFFFFF">
+                  <a:alpha val="0"/>
+                </a:srgbClr>
+              </a:clrTo>
+            </a:clrChange>
+          </a:blip>
           <a:stretch>
             <a:fillRect/>
           </a:stretch>
         </p:blipFill>
         <p:spPr>
           <a:xfrm>
-            <a:off x="7142593" y="11446786"/>
+            <a:off x="5749144" y="10291989"/>
             <a:ext cx="5143500" cy="5143500"/>
           </a:xfrm>
           <a:prstGeom prst="rect">
@@ -9688,14 +9721,25 @@
           <p:nvPr/>
         </p:nvPicPr>
         <p:blipFill>
-          <a:blip r:embed="rId5"/>
+          <a:blip r:embed="rId5">
+            <a:clrChange>
+              <a:clrFrom>
+                <a:srgbClr val="FFFFFF"/>
+              </a:clrFrom>
+              <a:clrTo>
+                <a:srgbClr val="FFFFFF">
+                  <a:alpha val="0"/>
+                </a:srgbClr>
+              </a:clrTo>
+            </a:clrChange>
+          </a:blip>
           <a:stretch>
             <a:fillRect/>
           </a:stretch>
         </p:blipFill>
         <p:spPr>
           <a:xfrm>
-            <a:off x="15354751" y="4530638"/>
+            <a:off x="11206084" y="7938255"/>
             <a:ext cx="5232400" cy="5232400"/>
           </a:xfrm>
           <a:prstGeom prst="rect">
@@ -9718,14 +9762,25 @@
           <p:nvPr/>
         </p:nvPicPr>
         <p:blipFill>
-          <a:blip r:embed="rId6"/>
+          <a:blip r:embed="rId6">
+            <a:clrChange>
+              <a:clrFrom>
+                <a:srgbClr val="FFFFFF"/>
+              </a:clrFrom>
+              <a:clrTo>
+                <a:srgbClr val="FFFFFF">
+                  <a:alpha val="0"/>
+                </a:srgbClr>
+              </a:clrTo>
+            </a:clrChange>
+          </a:blip>
           <a:stretch>
             <a:fillRect/>
           </a:stretch>
         </p:blipFill>
         <p:spPr>
           <a:xfrm>
-            <a:off x="-482308" y="6363455"/>
+            <a:off x="-475580" y="7938255"/>
             <a:ext cx="5334000" cy="5359400"/>
           </a:xfrm>
           <a:prstGeom prst="rect">

</xml_diff>

<commit_message>
adds color to icons
</commit_message>
<xml_diff>
--- a/logos/logos.pptx
+++ b/logos/logos.pptx
@@ -261,7 +261,7 @@
           <a:p>
             <a:fld id="{16F93EB0-79FE-3A48-9677-781C433206CF}" type="datetimeFigureOut">
               <a:rPr lang="en-US" smtClean="0"/>
-              <a:t>8/24/21</a:t>
+              <a:t>8/28/21</a:t>
             </a:fld>
             <a:endParaRPr lang="en-US"/>
           </a:p>
@@ -461,7 +461,7 @@
           <a:p>
             <a:fld id="{16F93EB0-79FE-3A48-9677-781C433206CF}" type="datetimeFigureOut">
               <a:rPr lang="en-US" smtClean="0"/>
-              <a:t>8/24/21</a:t>
+              <a:t>8/28/21</a:t>
             </a:fld>
             <a:endParaRPr lang="en-US"/>
           </a:p>
@@ -671,7 +671,7 @@
           <a:p>
             <a:fld id="{16F93EB0-79FE-3A48-9677-781C433206CF}" type="datetimeFigureOut">
               <a:rPr lang="en-US" smtClean="0"/>
-              <a:t>8/24/21</a:t>
+              <a:t>8/28/21</a:t>
             </a:fld>
             <a:endParaRPr lang="en-US"/>
           </a:p>
@@ -871,7 +871,7 @@
           <a:p>
             <a:fld id="{16F93EB0-79FE-3A48-9677-781C433206CF}" type="datetimeFigureOut">
               <a:rPr lang="en-US" smtClean="0"/>
-              <a:t>8/24/21</a:t>
+              <a:t>8/28/21</a:t>
             </a:fld>
             <a:endParaRPr lang="en-US"/>
           </a:p>
@@ -1147,7 +1147,7 @@
           <a:p>
             <a:fld id="{16F93EB0-79FE-3A48-9677-781C433206CF}" type="datetimeFigureOut">
               <a:rPr lang="en-US" smtClean="0"/>
-              <a:t>8/24/21</a:t>
+              <a:t>8/28/21</a:t>
             </a:fld>
             <a:endParaRPr lang="en-US"/>
           </a:p>
@@ -1415,7 +1415,7 @@
           <a:p>
             <a:fld id="{16F93EB0-79FE-3A48-9677-781C433206CF}" type="datetimeFigureOut">
               <a:rPr lang="en-US" smtClean="0"/>
-              <a:t>8/24/21</a:t>
+              <a:t>8/28/21</a:t>
             </a:fld>
             <a:endParaRPr lang="en-US"/>
           </a:p>
@@ -1830,7 +1830,7 @@
           <a:p>
             <a:fld id="{16F93EB0-79FE-3A48-9677-781C433206CF}" type="datetimeFigureOut">
               <a:rPr lang="en-US" smtClean="0"/>
-              <a:t>8/24/21</a:t>
+              <a:t>8/28/21</a:t>
             </a:fld>
             <a:endParaRPr lang="en-US"/>
           </a:p>
@@ -1972,7 +1972,7 @@
           <a:p>
             <a:fld id="{16F93EB0-79FE-3A48-9677-781C433206CF}" type="datetimeFigureOut">
               <a:rPr lang="en-US" smtClean="0"/>
-              <a:t>8/24/21</a:t>
+              <a:t>8/28/21</a:t>
             </a:fld>
             <a:endParaRPr lang="en-US"/>
           </a:p>
@@ -2085,7 +2085,7 @@
           <a:p>
             <a:fld id="{16F93EB0-79FE-3A48-9677-781C433206CF}" type="datetimeFigureOut">
               <a:rPr lang="en-US" smtClean="0"/>
-              <a:t>8/24/21</a:t>
+              <a:t>8/28/21</a:t>
             </a:fld>
             <a:endParaRPr lang="en-US"/>
           </a:p>
@@ -2398,7 +2398,7 @@
           <a:p>
             <a:fld id="{16F93EB0-79FE-3A48-9677-781C433206CF}" type="datetimeFigureOut">
               <a:rPr lang="en-US" smtClean="0"/>
-              <a:t>8/24/21</a:t>
+              <a:t>8/28/21</a:t>
             </a:fld>
             <a:endParaRPr lang="en-US"/>
           </a:p>
@@ -2687,7 +2687,7 @@
           <a:p>
             <a:fld id="{16F93EB0-79FE-3A48-9677-781C433206CF}" type="datetimeFigureOut">
               <a:rPr lang="en-US" smtClean="0"/>
-              <a:t>8/24/21</a:t>
+              <a:t>8/28/21</a:t>
             </a:fld>
             <a:endParaRPr lang="en-US"/>
           </a:p>
@@ -2930,7 +2930,7 @@
           <a:p>
             <a:fld id="{16F93EB0-79FE-3A48-9677-781C433206CF}" type="datetimeFigureOut">
               <a:rPr lang="en-US" smtClean="0"/>
-              <a:t>8/24/21</a:t>
+              <a:t>8/28/21</a:t>
             </a:fld>
             <a:endParaRPr lang="en-US"/>
           </a:p>
@@ -26448,6 +26448,1004 @@
           </a:prstGeom>
         </p:spPr>
       </p:pic>
+      <p:grpSp>
+        <p:nvGrpSpPr>
+          <p:cNvPr id="494" name="Group 493">
+            <a:extLst>
+              <a:ext uri="{FF2B5EF4-FFF2-40B4-BE49-F238E27FC236}">
+                <a16:creationId xmlns:a16="http://schemas.microsoft.com/office/drawing/2014/main" id="{4825365A-41F7-CC4B-839A-F9F2444548C4}"/>
+              </a:ext>
+            </a:extLst>
+          </p:cNvPr>
+          <p:cNvGrpSpPr/>
+          <p:nvPr/>
+        </p:nvGrpSpPr>
+        <p:grpSpPr>
+          <a:xfrm>
+            <a:off x="7959639" y="3319750"/>
+            <a:ext cx="535049" cy="482789"/>
+            <a:chOff x="6227183" y="2691999"/>
+            <a:chExt cx="418056" cy="377222"/>
+          </a:xfrm>
+        </p:grpSpPr>
+        <p:sp>
+          <p:nvSpPr>
+            <p:cNvPr id="495" name="Rectangle 494">
+              <a:extLst>
+                <a:ext uri="{FF2B5EF4-FFF2-40B4-BE49-F238E27FC236}">
+                  <a16:creationId xmlns:a16="http://schemas.microsoft.com/office/drawing/2014/main" id="{B200CF7F-211A-F249-B71A-77DD90927BD6}"/>
+                </a:ext>
+              </a:extLst>
+            </p:cNvPr>
+            <p:cNvSpPr/>
+            <p:nvPr/>
+          </p:nvSpPr>
+          <p:spPr>
+            <a:xfrm>
+              <a:off x="6233054" y="2869072"/>
+              <a:ext cx="412185" cy="200149"/>
+            </a:xfrm>
+            <a:prstGeom prst="rect">
+              <a:avLst/>
+            </a:prstGeom>
+            <a:solidFill>
+              <a:schemeClr val="bg1"/>
+            </a:solidFill>
+            <a:ln>
+              <a:noFill/>
+            </a:ln>
+          </p:spPr>
+          <p:style>
+            <a:lnRef idx="2">
+              <a:schemeClr val="accent1">
+                <a:shade val="50000"/>
+              </a:schemeClr>
+            </a:lnRef>
+            <a:fillRef idx="1">
+              <a:schemeClr val="accent1"/>
+            </a:fillRef>
+            <a:effectRef idx="0">
+              <a:schemeClr val="accent1"/>
+            </a:effectRef>
+            <a:fontRef idx="minor">
+              <a:schemeClr val="lt1"/>
+            </a:fontRef>
+          </p:style>
+          <p:txBody>
+            <a:bodyPr rtlCol="0" anchor="ctr"/>
+            <a:lstStyle/>
+            <a:p>
+              <a:pPr algn="ctr"/>
+              <a:endParaRPr lang="en-US"/>
+            </a:p>
+          </p:txBody>
+        </p:sp>
+        <p:grpSp>
+          <p:nvGrpSpPr>
+            <p:cNvPr id="496" name="Group 495">
+              <a:extLst>
+                <a:ext uri="{FF2B5EF4-FFF2-40B4-BE49-F238E27FC236}">
+                  <a16:creationId xmlns:a16="http://schemas.microsoft.com/office/drawing/2014/main" id="{8F916719-94FC-434C-BFF7-C327721A6BF0}"/>
+                </a:ext>
+              </a:extLst>
+            </p:cNvPr>
+            <p:cNvGrpSpPr/>
+            <p:nvPr/>
+          </p:nvGrpSpPr>
+          <p:grpSpPr>
+            <a:xfrm>
+              <a:off x="6227183" y="2691999"/>
+              <a:ext cx="373276" cy="354952"/>
+              <a:chOff x="6400534" y="1760400"/>
+              <a:chExt cx="302867" cy="288000"/>
+            </a:xfrm>
+          </p:grpSpPr>
+          <p:sp>
+            <p:nvSpPr>
+              <p:cNvPr id="497" name="Rectangle 496">
+                <a:extLst>
+                  <a:ext uri="{FF2B5EF4-FFF2-40B4-BE49-F238E27FC236}">
+                    <a16:creationId xmlns:a16="http://schemas.microsoft.com/office/drawing/2014/main" id="{4C84FA73-8E29-F24A-81FE-4244D7B1AA02}"/>
+                  </a:ext>
+                </a:extLst>
+              </p:cNvPr>
+              <p:cNvSpPr/>
+              <p:nvPr/>
+            </p:nvSpPr>
+            <p:spPr>
+              <a:xfrm>
+                <a:off x="6405181" y="2030400"/>
+                <a:ext cx="288000" cy="18000"/>
+              </a:xfrm>
+              <a:prstGeom prst="rect">
+                <a:avLst/>
+              </a:prstGeom>
+              <a:solidFill>
+                <a:schemeClr val="tx1"/>
+              </a:solidFill>
+              <a:ln w="19050">
+                <a:solidFill>
+                  <a:schemeClr val="tx1"/>
+                </a:solidFill>
+              </a:ln>
+            </p:spPr>
+            <p:style>
+              <a:lnRef idx="2">
+                <a:schemeClr val="accent1">
+                  <a:shade val="50000"/>
+                </a:schemeClr>
+              </a:lnRef>
+              <a:fillRef idx="1">
+                <a:schemeClr val="accent1"/>
+              </a:fillRef>
+              <a:effectRef idx="0">
+                <a:schemeClr val="accent1"/>
+              </a:effectRef>
+              <a:fontRef idx="minor">
+                <a:schemeClr val="lt1"/>
+              </a:fontRef>
+            </p:style>
+            <p:txBody>
+              <a:bodyPr rtlCol="0" anchor="ctr"/>
+              <a:lstStyle/>
+              <a:p>
+                <a:pPr algn="ctr"/>
+                <a:endParaRPr lang="en-US"/>
+              </a:p>
+            </p:txBody>
+          </p:sp>
+          <p:sp>
+            <p:nvSpPr>
+              <p:cNvPr id="498" name="Rectangle 497">
+                <a:extLst>
+                  <a:ext uri="{FF2B5EF4-FFF2-40B4-BE49-F238E27FC236}">
+                    <a16:creationId xmlns:a16="http://schemas.microsoft.com/office/drawing/2014/main" id="{50024883-C85C-2B4F-9495-A05276D27417}"/>
+                  </a:ext>
+                </a:extLst>
+              </p:cNvPr>
+              <p:cNvSpPr/>
+              <p:nvPr/>
+            </p:nvSpPr>
+            <p:spPr>
+              <a:xfrm rot="5400000">
+                <a:off x="6265534" y="1895400"/>
+                <a:ext cx="288000" cy="18000"/>
+              </a:xfrm>
+              <a:prstGeom prst="rect">
+                <a:avLst/>
+              </a:prstGeom>
+              <a:solidFill>
+                <a:schemeClr val="tx1"/>
+              </a:solidFill>
+              <a:ln w="19050">
+                <a:solidFill>
+                  <a:schemeClr val="tx1"/>
+                </a:solidFill>
+              </a:ln>
+            </p:spPr>
+            <p:style>
+              <a:lnRef idx="2">
+                <a:schemeClr val="accent1">
+                  <a:shade val="50000"/>
+                </a:schemeClr>
+              </a:lnRef>
+              <a:fillRef idx="1">
+                <a:schemeClr val="accent1"/>
+              </a:fillRef>
+              <a:effectRef idx="0">
+                <a:schemeClr val="accent1"/>
+              </a:effectRef>
+              <a:fontRef idx="minor">
+                <a:schemeClr val="lt1"/>
+              </a:fontRef>
+            </p:style>
+            <p:txBody>
+              <a:bodyPr rtlCol="0" anchor="ctr"/>
+              <a:lstStyle/>
+              <a:p>
+                <a:pPr algn="ctr"/>
+                <a:endParaRPr lang="en-US"/>
+              </a:p>
+            </p:txBody>
+          </p:sp>
+          <p:sp>
+            <p:nvSpPr>
+              <p:cNvPr id="499" name="Rectangle 498">
+                <a:extLst>
+                  <a:ext uri="{FF2B5EF4-FFF2-40B4-BE49-F238E27FC236}">
+                    <a16:creationId xmlns:a16="http://schemas.microsoft.com/office/drawing/2014/main" id="{5C0542BD-D652-574C-8A0D-E76053B48E8F}"/>
+                  </a:ext>
+                </a:extLst>
+              </p:cNvPr>
+              <p:cNvSpPr/>
+              <p:nvPr/>
+            </p:nvSpPr>
+            <p:spPr>
+              <a:xfrm rot="19077046">
+                <a:off x="6415401" y="1884276"/>
+                <a:ext cx="288000" cy="18000"/>
+              </a:xfrm>
+              <a:prstGeom prst="rect">
+                <a:avLst/>
+              </a:prstGeom>
+              <a:solidFill>
+                <a:schemeClr val="tx1"/>
+              </a:solidFill>
+              <a:ln w="19050">
+                <a:solidFill>
+                  <a:schemeClr val="tx1"/>
+                </a:solidFill>
+              </a:ln>
+            </p:spPr>
+            <p:style>
+              <a:lnRef idx="2">
+                <a:schemeClr val="accent1">
+                  <a:shade val="50000"/>
+                </a:schemeClr>
+              </a:lnRef>
+              <a:fillRef idx="1">
+                <a:schemeClr val="accent1"/>
+              </a:fillRef>
+              <a:effectRef idx="0">
+                <a:schemeClr val="accent1"/>
+              </a:effectRef>
+              <a:fontRef idx="minor">
+                <a:schemeClr val="lt1"/>
+              </a:fontRef>
+            </p:style>
+            <p:txBody>
+              <a:bodyPr rtlCol="0" anchor="ctr"/>
+              <a:lstStyle/>
+              <a:p>
+                <a:pPr algn="ctr"/>
+                <a:endParaRPr lang="en-US"/>
+              </a:p>
+            </p:txBody>
+          </p:sp>
+          <p:sp>
+            <p:nvSpPr>
+              <p:cNvPr id="500" name="Oval 499">
+                <a:extLst>
+                  <a:ext uri="{FF2B5EF4-FFF2-40B4-BE49-F238E27FC236}">
+                    <a16:creationId xmlns:a16="http://schemas.microsoft.com/office/drawing/2014/main" id="{378DA487-5027-4A4C-B404-A8A4933FBA1D}"/>
+                  </a:ext>
+                </a:extLst>
+              </p:cNvPr>
+              <p:cNvSpPr/>
+              <p:nvPr/>
+            </p:nvSpPr>
+            <p:spPr>
+              <a:xfrm>
+                <a:off x="6472750" y="1878430"/>
+                <a:ext cx="45719" cy="45719"/>
+              </a:xfrm>
+              <a:prstGeom prst="ellipse">
+                <a:avLst/>
+              </a:prstGeom>
+              <a:solidFill>
+                <a:schemeClr val="tx1"/>
+              </a:solidFill>
+              <a:ln w="6350">
+                <a:solidFill>
+                  <a:schemeClr val="tx1"/>
+                </a:solidFill>
+              </a:ln>
+            </p:spPr>
+            <p:style>
+              <a:lnRef idx="2">
+                <a:schemeClr val="accent1">
+                  <a:shade val="50000"/>
+                </a:schemeClr>
+              </a:lnRef>
+              <a:fillRef idx="1">
+                <a:schemeClr val="accent1"/>
+              </a:fillRef>
+              <a:effectRef idx="0">
+                <a:schemeClr val="accent1"/>
+              </a:effectRef>
+              <a:fontRef idx="minor">
+                <a:schemeClr val="lt1"/>
+              </a:fontRef>
+            </p:style>
+            <p:txBody>
+              <a:bodyPr rtlCol="0" anchor="ctr"/>
+              <a:lstStyle/>
+              <a:p>
+                <a:pPr algn="ctr"/>
+                <a:endParaRPr lang="en-US"/>
+              </a:p>
+            </p:txBody>
+          </p:sp>
+          <p:sp>
+            <p:nvSpPr>
+              <p:cNvPr id="501" name="Oval 500">
+                <a:extLst>
+                  <a:ext uri="{FF2B5EF4-FFF2-40B4-BE49-F238E27FC236}">
+                    <a16:creationId xmlns:a16="http://schemas.microsoft.com/office/drawing/2014/main" id="{818C3961-DAF5-6643-9C5C-2E215396958F}"/>
+                  </a:ext>
+                </a:extLst>
+              </p:cNvPr>
+              <p:cNvSpPr/>
+              <p:nvPr/>
+            </p:nvSpPr>
+            <p:spPr>
+              <a:xfrm>
+                <a:off x="6527050" y="1819949"/>
+                <a:ext cx="45719" cy="45719"/>
+              </a:xfrm>
+              <a:prstGeom prst="ellipse">
+                <a:avLst/>
+              </a:prstGeom>
+              <a:solidFill>
+                <a:schemeClr val="tx1"/>
+              </a:solidFill>
+              <a:ln w="6350">
+                <a:solidFill>
+                  <a:schemeClr val="tx1"/>
+                </a:solidFill>
+              </a:ln>
+            </p:spPr>
+            <p:style>
+              <a:lnRef idx="2">
+                <a:schemeClr val="accent1">
+                  <a:shade val="50000"/>
+                </a:schemeClr>
+              </a:lnRef>
+              <a:fillRef idx="1">
+                <a:schemeClr val="accent1"/>
+              </a:fillRef>
+              <a:effectRef idx="0">
+                <a:schemeClr val="accent1"/>
+              </a:effectRef>
+              <a:fontRef idx="minor">
+                <a:schemeClr val="lt1"/>
+              </a:fontRef>
+            </p:style>
+            <p:txBody>
+              <a:bodyPr rtlCol="0" anchor="ctr"/>
+              <a:lstStyle/>
+              <a:p>
+                <a:pPr algn="ctr"/>
+                <a:endParaRPr lang="en-US"/>
+              </a:p>
+            </p:txBody>
+          </p:sp>
+          <p:sp>
+            <p:nvSpPr>
+              <p:cNvPr id="502" name="Oval 501">
+                <a:extLst>
+                  <a:ext uri="{FF2B5EF4-FFF2-40B4-BE49-F238E27FC236}">
+                    <a16:creationId xmlns:a16="http://schemas.microsoft.com/office/drawing/2014/main" id="{589A2672-A439-9043-8172-14D347D14D92}"/>
+                  </a:ext>
+                </a:extLst>
+              </p:cNvPr>
+              <p:cNvSpPr/>
+              <p:nvPr/>
+            </p:nvSpPr>
+            <p:spPr>
+              <a:xfrm>
+                <a:off x="6540673" y="1888255"/>
+                <a:ext cx="45719" cy="45719"/>
+              </a:xfrm>
+              <a:prstGeom prst="ellipse">
+                <a:avLst/>
+              </a:prstGeom>
+              <a:solidFill>
+                <a:schemeClr val="tx1"/>
+              </a:solidFill>
+              <a:ln w="6350">
+                <a:solidFill>
+                  <a:schemeClr val="tx1"/>
+                </a:solidFill>
+              </a:ln>
+            </p:spPr>
+            <p:style>
+              <a:lnRef idx="2">
+                <a:schemeClr val="accent1">
+                  <a:shade val="50000"/>
+                </a:schemeClr>
+              </a:lnRef>
+              <a:fillRef idx="1">
+                <a:schemeClr val="accent1"/>
+              </a:fillRef>
+              <a:effectRef idx="0">
+                <a:schemeClr val="accent1"/>
+              </a:effectRef>
+              <a:fontRef idx="minor">
+                <a:schemeClr val="lt1"/>
+              </a:fontRef>
+            </p:style>
+            <p:txBody>
+              <a:bodyPr rtlCol="0" anchor="ctr"/>
+              <a:lstStyle/>
+              <a:p>
+                <a:pPr algn="ctr"/>
+                <a:endParaRPr lang="en-US"/>
+              </a:p>
+            </p:txBody>
+          </p:sp>
+          <p:sp>
+            <p:nvSpPr>
+              <p:cNvPr id="503" name="Oval 502">
+                <a:extLst>
+                  <a:ext uri="{FF2B5EF4-FFF2-40B4-BE49-F238E27FC236}">
+                    <a16:creationId xmlns:a16="http://schemas.microsoft.com/office/drawing/2014/main" id="{FF1AA6EC-F408-8041-AC24-3CDEB80C011C}"/>
+                  </a:ext>
+                </a:extLst>
+              </p:cNvPr>
+              <p:cNvSpPr/>
+              <p:nvPr/>
+            </p:nvSpPr>
+            <p:spPr>
+              <a:xfrm>
+                <a:off x="6456113" y="1953950"/>
+                <a:ext cx="45719" cy="45719"/>
+              </a:xfrm>
+              <a:prstGeom prst="ellipse">
+                <a:avLst/>
+              </a:prstGeom>
+              <a:solidFill>
+                <a:schemeClr val="tx1"/>
+              </a:solidFill>
+              <a:ln w="6350">
+                <a:solidFill>
+                  <a:schemeClr val="tx1"/>
+                </a:solidFill>
+              </a:ln>
+            </p:spPr>
+            <p:style>
+              <a:lnRef idx="2">
+                <a:schemeClr val="accent1">
+                  <a:shade val="50000"/>
+                </a:schemeClr>
+              </a:lnRef>
+              <a:fillRef idx="1">
+                <a:schemeClr val="accent1"/>
+              </a:fillRef>
+              <a:effectRef idx="0">
+                <a:schemeClr val="accent1"/>
+              </a:effectRef>
+              <a:fontRef idx="minor">
+                <a:schemeClr val="lt1"/>
+              </a:fontRef>
+            </p:style>
+            <p:txBody>
+              <a:bodyPr rtlCol="0" anchor="ctr"/>
+              <a:lstStyle/>
+              <a:p>
+                <a:pPr algn="ctr"/>
+                <a:endParaRPr lang="en-US"/>
+              </a:p>
+            </p:txBody>
+          </p:sp>
+          <p:sp>
+            <p:nvSpPr>
+              <p:cNvPr id="504" name="Oval 503">
+                <a:extLst>
+                  <a:ext uri="{FF2B5EF4-FFF2-40B4-BE49-F238E27FC236}">
+                    <a16:creationId xmlns:a16="http://schemas.microsoft.com/office/drawing/2014/main" id="{93A03DEF-02EF-0C4B-9D6A-23E9EA639D4E}"/>
+                  </a:ext>
+                </a:extLst>
+              </p:cNvPr>
+              <p:cNvSpPr/>
+              <p:nvPr/>
+            </p:nvSpPr>
+            <p:spPr>
+              <a:xfrm>
+                <a:off x="6515244" y="1941800"/>
+                <a:ext cx="45719" cy="45719"/>
+              </a:xfrm>
+              <a:prstGeom prst="ellipse">
+                <a:avLst/>
+              </a:prstGeom>
+              <a:solidFill>
+                <a:schemeClr val="tx1"/>
+              </a:solidFill>
+              <a:ln w="6350">
+                <a:solidFill>
+                  <a:schemeClr val="tx1"/>
+                </a:solidFill>
+              </a:ln>
+            </p:spPr>
+            <p:style>
+              <a:lnRef idx="2">
+                <a:schemeClr val="accent1">
+                  <a:shade val="50000"/>
+                </a:schemeClr>
+              </a:lnRef>
+              <a:fillRef idx="1">
+                <a:schemeClr val="accent1"/>
+              </a:fillRef>
+              <a:effectRef idx="0">
+                <a:schemeClr val="accent1"/>
+              </a:effectRef>
+              <a:fontRef idx="minor">
+                <a:schemeClr val="lt1"/>
+              </a:fontRef>
+            </p:style>
+            <p:txBody>
+              <a:bodyPr rtlCol="0" anchor="ctr"/>
+              <a:lstStyle/>
+              <a:p>
+                <a:pPr algn="ctr"/>
+                <a:endParaRPr lang="en-US"/>
+              </a:p>
+            </p:txBody>
+          </p:sp>
+          <p:sp>
+            <p:nvSpPr>
+              <p:cNvPr id="505" name="Oval 504">
+                <a:extLst>
+                  <a:ext uri="{FF2B5EF4-FFF2-40B4-BE49-F238E27FC236}">
+                    <a16:creationId xmlns:a16="http://schemas.microsoft.com/office/drawing/2014/main" id="{278BBDC7-E9FD-5849-AB0A-9C67D4AF6F51}"/>
+                  </a:ext>
+                </a:extLst>
+              </p:cNvPr>
+              <p:cNvSpPr/>
+              <p:nvPr/>
+            </p:nvSpPr>
+            <p:spPr>
+              <a:xfrm>
+                <a:off x="6582490" y="1809229"/>
+                <a:ext cx="45719" cy="45719"/>
+              </a:xfrm>
+              <a:prstGeom prst="ellipse">
+                <a:avLst/>
+              </a:prstGeom>
+              <a:solidFill>
+                <a:schemeClr val="tx1"/>
+              </a:solidFill>
+              <a:ln w="6350">
+                <a:solidFill>
+                  <a:schemeClr val="tx1"/>
+                </a:solidFill>
+              </a:ln>
+            </p:spPr>
+            <p:style>
+              <a:lnRef idx="2">
+                <a:schemeClr val="accent1">
+                  <a:shade val="50000"/>
+                </a:schemeClr>
+              </a:lnRef>
+              <a:fillRef idx="1">
+                <a:schemeClr val="accent1"/>
+              </a:fillRef>
+              <a:effectRef idx="0">
+                <a:schemeClr val="accent1"/>
+              </a:effectRef>
+              <a:fontRef idx="minor">
+                <a:schemeClr val="lt1"/>
+              </a:fontRef>
+            </p:style>
+            <p:txBody>
+              <a:bodyPr rtlCol="0" anchor="ctr"/>
+              <a:lstStyle/>
+              <a:p>
+                <a:pPr algn="ctr"/>
+                <a:endParaRPr lang="en-US"/>
+              </a:p>
+            </p:txBody>
+          </p:sp>
+          <p:sp>
+            <p:nvSpPr>
+              <p:cNvPr id="506" name="Oval 505">
+                <a:extLst>
+                  <a:ext uri="{FF2B5EF4-FFF2-40B4-BE49-F238E27FC236}">
+                    <a16:creationId xmlns:a16="http://schemas.microsoft.com/office/drawing/2014/main" id="{2919F4DA-6A2E-ED42-AEC3-A572B924670D}"/>
+                  </a:ext>
+                </a:extLst>
+              </p:cNvPr>
+              <p:cNvSpPr/>
+              <p:nvPr/>
+            </p:nvSpPr>
+            <p:spPr>
+              <a:xfrm>
+                <a:off x="6605737" y="1874242"/>
+                <a:ext cx="45719" cy="45719"/>
+              </a:xfrm>
+              <a:prstGeom prst="ellipse">
+                <a:avLst/>
+              </a:prstGeom>
+              <a:solidFill>
+                <a:schemeClr val="tx1"/>
+              </a:solidFill>
+              <a:ln w="6350">
+                <a:solidFill>
+                  <a:schemeClr val="tx1"/>
+                </a:solidFill>
+              </a:ln>
+            </p:spPr>
+            <p:style>
+              <a:lnRef idx="2">
+                <a:schemeClr val="accent1">
+                  <a:shade val="50000"/>
+                </a:schemeClr>
+              </a:lnRef>
+              <a:fillRef idx="1">
+                <a:schemeClr val="accent1"/>
+              </a:fillRef>
+              <a:effectRef idx="0">
+                <a:schemeClr val="accent1"/>
+              </a:effectRef>
+              <a:fontRef idx="minor">
+                <a:schemeClr val="lt1"/>
+              </a:fontRef>
+            </p:style>
+            <p:txBody>
+              <a:bodyPr rtlCol="0" anchor="ctr"/>
+              <a:lstStyle/>
+              <a:p>
+                <a:pPr algn="ctr"/>
+                <a:endParaRPr lang="en-US"/>
+              </a:p>
+            </p:txBody>
+          </p:sp>
+          <p:sp>
+            <p:nvSpPr>
+              <p:cNvPr id="508" name="Oval 507">
+                <a:extLst>
+                  <a:ext uri="{FF2B5EF4-FFF2-40B4-BE49-F238E27FC236}">
+                    <a16:creationId xmlns:a16="http://schemas.microsoft.com/office/drawing/2014/main" id="{88AA6C3D-934C-704F-830B-839FE63D2840}"/>
+                  </a:ext>
+                </a:extLst>
+              </p:cNvPr>
+              <p:cNvSpPr/>
+              <p:nvPr/>
+            </p:nvSpPr>
+            <p:spPr>
+              <a:xfrm>
+                <a:off x="6651456" y="1813910"/>
+                <a:ext cx="45719" cy="45719"/>
+              </a:xfrm>
+              <a:prstGeom prst="ellipse">
+                <a:avLst/>
+              </a:prstGeom>
+              <a:solidFill>
+                <a:schemeClr val="tx1"/>
+              </a:solidFill>
+              <a:ln w="6350">
+                <a:solidFill>
+                  <a:schemeClr val="tx1"/>
+                </a:solidFill>
+              </a:ln>
+            </p:spPr>
+            <p:style>
+              <a:lnRef idx="2">
+                <a:schemeClr val="accent1">
+                  <a:shade val="50000"/>
+                </a:schemeClr>
+              </a:lnRef>
+              <a:fillRef idx="1">
+                <a:schemeClr val="accent1"/>
+              </a:fillRef>
+              <a:effectRef idx="0">
+                <a:schemeClr val="accent1"/>
+              </a:effectRef>
+              <a:fontRef idx="minor">
+                <a:schemeClr val="lt1"/>
+              </a:fontRef>
+            </p:style>
+            <p:txBody>
+              <a:bodyPr rtlCol="0" anchor="ctr"/>
+              <a:lstStyle/>
+              <a:p>
+                <a:pPr algn="ctr"/>
+                <a:endParaRPr lang="en-US"/>
+              </a:p>
+            </p:txBody>
+          </p:sp>
+        </p:grpSp>
+      </p:grpSp>
+      <p:grpSp>
+        <p:nvGrpSpPr>
+          <p:cNvPr id="519" name="Group 518">
+            <a:extLst>
+              <a:ext uri="{FF2B5EF4-FFF2-40B4-BE49-F238E27FC236}">
+                <a16:creationId xmlns:a16="http://schemas.microsoft.com/office/drawing/2014/main" id="{1CB7020A-1FAA-B64C-8706-BBA67DCEC25E}"/>
+              </a:ext>
+            </a:extLst>
+          </p:cNvPr>
+          <p:cNvGrpSpPr/>
+          <p:nvPr/>
+        </p:nvGrpSpPr>
+        <p:grpSpPr>
+          <a:xfrm>
+            <a:off x="7804601" y="2532862"/>
+            <a:ext cx="476607" cy="377945"/>
+            <a:chOff x="6247282" y="2333992"/>
+            <a:chExt cx="365810" cy="290084"/>
+          </a:xfrm>
+        </p:grpSpPr>
+        <p:sp>
+          <p:nvSpPr>
+            <p:cNvPr id="522" name="Rectangle 521">
+              <a:extLst>
+                <a:ext uri="{FF2B5EF4-FFF2-40B4-BE49-F238E27FC236}">
+                  <a16:creationId xmlns:a16="http://schemas.microsoft.com/office/drawing/2014/main" id="{77099642-9E07-3845-A3FD-50B8AFF20C47}"/>
+                </a:ext>
+              </a:extLst>
+            </p:cNvPr>
+            <p:cNvSpPr/>
+            <p:nvPr/>
+          </p:nvSpPr>
+          <p:spPr>
+            <a:xfrm>
+              <a:off x="6247282" y="2333992"/>
+              <a:ext cx="365810" cy="290084"/>
+            </a:xfrm>
+            <a:prstGeom prst="rect">
+              <a:avLst/>
+            </a:prstGeom>
+            <a:solidFill>
+              <a:schemeClr val="bg1"/>
+            </a:solidFill>
+            <a:ln>
+              <a:noFill/>
+            </a:ln>
+          </p:spPr>
+          <p:style>
+            <a:lnRef idx="2">
+              <a:schemeClr val="accent1">
+                <a:shade val="50000"/>
+              </a:schemeClr>
+            </a:lnRef>
+            <a:fillRef idx="1">
+              <a:schemeClr val="accent1"/>
+            </a:fillRef>
+            <a:effectRef idx="0">
+              <a:schemeClr val="accent1"/>
+            </a:effectRef>
+            <a:fontRef idx="minor">
+              <a:schemeClr val="lt1"/>
+            </a:fontRef>
+          </p:style>
+          <p:txBody>
+            <a:bodyPr rtlCol="0" anchor="ctr"/>
+            <a:lstStyle/>
+            <a:p>
+              <a:pPr algn="ctr"/>
+              <a:endParaRPr lang="en-US"/>
+            </a:p>
+          </p:txBody>
+        </p:sp>
+        <p:grpSp>
+          <p:nvGrpSpPr>
+            <p:cNvPr id="523" name="Group 522">
+              <a:extLst>
+                <a:ext uri="{FF2B5EF4-FFF2-40B4-BE49-F238E27FC236}">
+                  <a16:creationId xmlns:a16="http://schemas.microsoft.com/office/drawing/2014/main" id="{FF3A8C10-DD59-7A49-9C58-FB2789A95AE1}"/>
+                </a:ext>
+              </a:extLst>
+            </p:cNvPr>
+            <p:cNvGrpSpPr/>
+            <p:nvPr/>
+          </p:nvGrpSpPr>
+          <p:grpSpPr>
+            <a:xfrm>
+              <a:off x="6248724" y="2363625"/>
+              <a:ext cx="349221" cy="223307"/>
+              <a:chOff x="5770832" y="1560161"/>
+              <a:chExt cx="346385" cy="181525"/>
+            </a:xfrm>
+          </p:grpSpPr>
+          <p:sp>
+            <p:nvSpPr>
+              <p:cNvPr id="524" name="Rectangle 523">
+                <a:extLst>
+                  <a:ext uri="{FF2B5EF4-FFF2-40B4-BE49-F238E27FC236}">
+                    <a16:creationId xmlns:a16="http://schemas.microsoft.com/office/drawing/2014/main" id="{C558A689-1877-2740-AF81-D458D9181600}"/>
+                  </a:ext>
+                </a:extLst>
+              </p:cNvPr>
+              <p:cNvSpPr/>
+              <p:nvPr/>
+            </p:nvSpPr>
+            <p:spPr>
+              <a:xfrm>
+                <a:off x="5803713" y="1560161"/>
+                <a:ext cx="67891" cy="177982"/>
+              </a:xfrm>
+              <a:prstGeom prst="rect">
+                <a:avLst/>
+              </a:prstGeom>
+              <a:solidFill>
+                <a:schemeClr val="tx1"/>
+              </a:solidFill>
+              <a:ln w="19050">
+                <a:solidFill>
+                  <a:schemeClr val="tx1"/>
+                </a:solidFill>
+              </a:ln>
+            </p:spPr>
+            <p:style>
+              <a:lnRef idx="2">
+                <a:schemeClr val="accent1">
+                  <a:shade val="50000"/>
+                </a:schemeClr>
+              </a:lnRef>
+              <a:fillRef idx="1">
+                <a:schemeClr val="accent1"/>
+              </a:fillRef>
+              <a:effectRef idx="0">
+                <a:schemeClr val="accent1"/>
+              </a:effectRef>
+              <a:fontRef idx="minor">
+                <a:schemeClr val="lt1"/>
+              </a:fontRef>
+            </p:style>
+            <p:txBody>
+              <a:bodyPr rtlCol="0" anchor="ctr"/>
+              <a:lstStyle/>
+              <a:p>
+                <a:pPr algn="ctr"/>
+                <a:endParaRPr lang="en-US"/>
+              </a:p>
+            </p:txBody>
+          </p:sp>
+          <p:sp>
+            <p:nvSpPr>
+              <p:cNvPr id="525" name="Rectangle 524">
+                <a:extLst>
+                  <a:ext uri="{FF2B5EF4-FFF2-40B4-BE49-F238E27FC236}">
+                    <a16:creationId xmlns:a16="http://schemas.microsoft.com/office/drawing/2014/main" id="{D26070EF-0FDE-1441-8A26-BA27CFD96D65}"/>
+                  </a:ext>
+                </a:extLst>
+              </p:cNvPr>
+              <p:cNvSpPr/>
+              <p:nvPr/>
+            </p:nvSpPr>
+            <p:spPr>
+              <a:xfrm>
+                <a:off x="5905943" y="1597910"/>
+                <a:ext cx="74277" cy="140234"/>
+              </a:xfrm>
+              <a:prstGeom prst="rect">
+                <a:avLst/>
+              </a:prstGeom>
+              <a:solidFill>
+                <a:schemeClr val="tx1"/>
+              </a:solidFill>
+              <a:ln w="19050">
+                <a:solidFill>
+                  <a:schemeClr val="tx1"/>
+                </a:solidFill>
+              </a:ln>
+            </p:spPr>
+            <p:style>
+              <a:lnRef idx="2">
+                <a:schemeClr val="accent1">
+                  <a:shade val="50000"/>
+                </a:schemeClr>
+              </a:lnRef>
+              <a:fillRef idx="1">
+                <a:schemeClr val="accent1"/>
+              </a:fillRef>
+              <a:effectRef idx="0">
+                <a:schemeClr val="accent1"/>
+              </a:effectRef>
+              <a:fontRef idx="minor">
+                <a:schemeClr val="lt1"/>
+              </a:fontRef>
+            </p:style>
+            <p:txBody>
+              <a:bodyPr rtlCol="0" anchor="ctr"/>
+              <a:lstStyle/>
+              <a:p>
+                <a:pPr algn="ctr"/>
+                <a:endParaRPr lang="en-US"/>
+              </a:p>
+            </p:txBody>
+          </p:sp>
+          <p:sp>
+            <p:nvSpPr>
+              <p:cNvPr id="527" name="Rectangle 526">
+                <a:extLst>
+                  <a:ext uri="{FF2B5EF4-FFF2-40B4-BE49-F238E27FC236}">
+                    <a16:creationId xmlns:a16="http://schemas.microsoft.com/office/drawing/2014/main" id="{9396C55C-EA51-5F46-AA51-F65640C6C25A}"/>
+                  </a:ext>
+                </a:extLst>
+              </p:cNvPr>
+              <p:cNvSpPr/>
+              <p:nvPr/>
+            </p:nvSpPr>
+            <p:spPr>
+              <a:xfrm>
+                <a:off x="6008601" y="1660525"/>
+                <a:ext cx="79854" cy="76204"/>
+              </a:xfrm>
+              <a:prstGeom prst="rect">
+                <a:avLst/>
+              </a:prstGeom>
+              <a:solidFill>
+                <a:schemeClr val="tx1"/>
+              </a:solidFill>
+              <a:ln w="19050">
+                <a:solidFill>
+                  <a:schemeClr val="tx1"/>
+                </a:solidFill>
+              </a:ln>
+            </p:spPr>
+            <p:style>
+              <a:lnRef idx="2">
+                <a:schemeClr val="accent1">
+                  <a:shade val="50000"/>
+                </a:schemeClr>
+              </a:lnRef>
+              <a:fillRef idx="1">
+                <a:schemeClr val="accent1"/>
+              </a:fillRef>
+              <a:effectRef idx="0">
+                <a:schemeClr val="accent1"/>
+              </a:effectRef>
+              <a:fontRef idx="minor">
+                <a:schemeClr val="lt1"/>
+              </a:fontRef>
+            </p:style>
+            <p:txBody>
+              <a:bodyPr rtlCol="0" anchor="ctr"/>
+              <a:lstStyle/>
+              <a:p>
+                <a:pPr algn="ctr"/>
+                <a:endParaRPr lang="en-US"/>
+              </a:p>
+            </p:txBody>
+          </p:sp>
+          <p:sp>
+            <p:nvSpPr>
+              <p:cNvPr id="529" name="Rectangle 528">
+                <a:extLst>
+                  <a:ext uri="{FF2B5EF4-FFF2-40B4-BE49-F238E27FC236}">
+                    <a16:creationId xmlns:a16="http://schemas.microsoft.com/office/drawing/2014/main" id="{C8016662-117A-DE4F-93EB-996EF1F09AAF}"/>
+                  </a:ext>
+                </a:extLst>
+              </p:cNvPr>
+              <p:cNvSpPr/>
+              <p:nvPr/>
+            </p:nvSpPr>
+            <p:spPr>
+              <a:xfrm>
+                <a:off x="5770832" y="1728903"/>
+                <a:ext cx="346385" cy="12783"/>
+              </a:xfrm>
+              <a:prstGeom prst="rect">
+                <a:avLst/>
+              </a:prstGeom>
+              <a:solidFill>
+                <a:schemeClr val="tx1"/>
+              </a:solidFill>
+              <a:ln w="19050">
+                <a:solidFill>
+                  <a:schemeClr val="tx1"/>
+                </a:solidFill>
+              </a:ln>
+            </p:spPr>
+            <p:style>
+              <a:lnRef idx="2">
+                <a:schemeClr val="accent1">
+                  <a:shade val="50000"/>
+                </a:schemeClr>
+              </a:lnRef>
+              <a:fillRef idx="1">
+                <a:schemeClr val="accent1"/>
+              </a:fillRef>
+              <a:effectRef idx="0">
+                <a:schemeClr val="accent1"/>
+              </a:effectRef>
+              <a:fontRef idx="minor">
+                <a:schemeClr val="lt1"/>
+              </a:fontRef>
+            </p:style>
+            <p:txBody>
+              <a:bodyPr rtlCol="0" anchor="ctr"/>
+              <a:lstStyle/>
+              <a:p>
+                <a:pPr algn="ctr"/>
+                <a:endParaRPr lang="en-US"/>
+              </a:p>
+            </p:txBody>
+          </p:sp>
+        </p:grpSp>
+      </p:grpSp>
     </p:spTree>
     <p:extLst>
       <p:ext uri="{BB962C8B-B14F-4D97-AF65-F5344CB8AC3E}">

</xml_diff>

<commit_message>
reshapes the teaching page
</commit_message>
<xml_diff>
--- a/logos/logos.pptx
+++ b/logos/logos.pptx
@@ -261,7 +261,7 @@
           <a:p>
             <a:fld id="{16F93EB0-79FE-3A48-9677-781C433206CF}" type="datetimeFigureOut">
               <a:rPr lang="en-US" smtClean="0"/>
-              <a:t>8/28/21</a:t>
+              <a:t>8/30/21</a:t>
             </a:fld>
             <a:endParaRPr lang="en-US"/>
           </a:p>
@@ -461,7 +461,7 @@
           <a:p>
             <a:fld id="{16F93EB0-79FE-3A48-9677-781C433206CF}" type="datetimeFigureOut">
               <a:rPr lang="en-US" smtClean="0"/>
-              <a:t>8/28/21</a:t>
+              <a:t>8/30/21</a:t>
             </a:fld>
             <a:endParaRPr lang="en-US"/>
           </a:p>
@@ -671,7 +671,7 @@
           <a:p>
             <a:fld id="{16F93EB0-79FE-3A48-9677-781C433206CF}" type="datetimeFigureOut">
               <a:rPr lang="en-US" smtClean="0"/>
-              <a:t>8/28/21</a:t>
+              <a:t>8/30/21</a:t>
             </a:fld>
             <a:endParaRPr lang="en-US"/>
           </a:p>
@@ -871,7 +871,7 @@
           <a:p>
             <a:fld id="{16F93EB0-79FE-3A48-9677-781C433206CF}" type="datetimeFigureOut">
               <a:rPr lang="en-US" smtClean="0"/>
-              <a:t>8/28/21</a:t>
+              <a:t>8/30/21</a:t>
             </a:fld>
             <a:endParaRPr lang="en-US"/>
           </a:p>
@@ -1147,7 +1147,7 @@
           <a:p>
             <a:fld id="{16F93EB0-79FE-3A48-9677-781C433206CF}" type="datetimeFigureOut">
               <a:rPr lang="en-US" smtClean="0"/>
-              <a:t>8/28/21</a:t>
+              <a:t>8/30/21</a:t>
             </a:fld>
             <a:endParaRPr lang="en-US"/>
           </a:p>
@@ -1415,7 +1415,7 @@
           <a:p>
             <a:fld id="{16F93EB0-79FE-3A48-9677-781C433206CF}" type="datetimeFigureOut">
               <a:rPr lang="en-US" smtClean="0"/>
-              <a:t>8/28/21</a:t>
+              <a:t>8/30/21</a:t>
             </a:fld>
             <a:endParaRPr lang="en-US"/>
           </a:p>
@@ -1830,7 +1830,7 @@
           <a:p>
             <a:fld id="{16F93EB0-79FE-3A48-9677-781C433206CF}" type="datetimeFigureOut">
               <a:rPr lang="en-US" smtClean="0"/>
-              <a:t>8/28/21</a:t>
+              <a:t>8/30/21</a:t>
             </a:fld>
             <a:endParaRPr lang="en-US"/>
           </a:p>
@@ -1972,7 +1972,7 @@
           <a:p>
             <a:fld id="{16F93EB0-79FE-3A48-9677-781C433206CF}" type="datetimeFigureOut">
               <a:rPr lang="en-US" smtClean="0"/>
-              <a:t>8/28/21</a:t>
+              <a:t>8/30/21</a:t>
             </a:fld>
             <a:endParaRPr lang="en-US"/>
           </a:p>
@@ -2085,7 +2085,7 @@
           <a:p>
             <a:fld id="{16F93EB0-79FE-3A48-9677-781C433206CF}" type="datetimeFigureOut">
               <a:rPr lang="en-US" smtClean="0"/>
-              <a:t>8/28/21</a:t>
+              <a:t>8/30/21</a:t>
             </a:fld>
             <a:endParaRPr lang="en-US"/>
           </a:p>
@@ -2398,7 +2398,7 @@
           <a:p>
             <a:fld id="{16F93EB0-79FE-3A48-9677-781C433206CF}" type="datetimeFigureOut">
               <a:rPr lang="en-US" smtClean="0"/>
-              <a:t>8/28/21</a:t>
+              <a:t>8/30/21</a:t>
             </a:fld>
             <a:endParaRPr lang="en-US"/>
           </a:p>
@@ -2687,7 +2687,7 @@
           <a:p>
             <a:fld id="{16F93EB0-79FE-3A48-9677-781C433206CF}" type="datetimeFigureOut">
               <a:rPr lang="en-US" smtClean="0"/>
-              <a:t>8/28/21</a:t>
+              <a:t>8/30/21</a:t>
             </a:fld>
             <a:endParaRPr lang="en-US"/>
           </a:p>
@@ -2930,7 +2930,7 @@
           <a:p>
             <a:fld id="{16F93EB0-79FE-3A48-9677-781C433206CF}" type="datetimeFigureOut">
               <a:rPr lang="en-US" smtClean="0"/>
-              <a:t>8/28/21</a:t>
+              <a:t>8/30/21</a:t>
             </a:fld>
             <a:endParaRPr lang="en-US"/>
           </a:p>
@@ -27446,6 +27446,733 @@
           </p:sp>
         </p:grpSp>
       </p:grpSp>
+      <p:grpSp>
+        <p:nvGrpSpPr>
+          <p:cNvPr id="531" name="Group 530">
+            <a:extLst>
+              <a:ext uri="{FF2B5EF4-FFF2-40B4-BE49-F238E27FC236}">
+                <a16:creationId xmlns:a16="http://schemas.microsoft.com/office/drawing/2014/main" id="{BBFD4A86-F8BB-214A-A146-7FEC120C801E}"/>
+              </a:ext>
+            </a:extLst>
+          </p:cNvPr>
+          <p:cNvGrpSpPr/>
+          <p:nvPr/>
+        </p:nvGrpSpPr>
+        <p:grpSpPr>
+          <a:xfrm>
+            <a:off x="9687460" y="3296976"/>
+            <a:ext cx="1322836" cy="1495710"/>
+            <a:chOff x="9818170" y="3088909"/>
+            <a:chExt cx="670592" cy="758227"/>
+          </a:xfrm>
+        </p:grpSpPr>
+        <p:sp>
+          <p:nvSpPr>
+            <p:cNvPr id="535" name="Terminator 534">
+              <a:extLst>
+                <a:ext uri="{FF2B5EF4-FFF2-40B4-BE49-F238E27FC236}">
+                  <a16:creationId xmlns:a16="http://schemas.microsoft.com/office/drawing/2014/main" id="{A5DB144E-E77B-F447-B0F0-43FFD899C04D}"/>
+                </a:ext>
+              </a:extLst>
+            </p:cNvPr>
+            <p:cNvSpPr/>
+            <p:nvPr/>
+          </p:nvSpPr>
+          <p:spPr>
+            <a:xfrm rot="17063310">
+              <a:off x="9666442" y="3545945"/>
+              <a:ext cx="452919" cy="149463"/>
+            </a:xfrm>
+            <a:prstGeom prst="flowChartTerminator">
+              <a:avLst/>
+            </a:prstGeom>
+            <a:solidFill>
+              <a:schemeClr val="tx1"/>
+            </a:solidFill>
+            <a:ln w="28575">
+              <a:solidFill>
+                <a:schemeClr val="bg1"/>
+              </a:solidFill>
+            </a:ln>
+          </p:spPr>
+          <p:style>
+            <a:lnRef idx="2">
+              <a:schemeClr val="accent1">
+                <a:shade val="50000"/>
+              </a:schemeClr>
+            </a:lnRef>
+            <a:fillRef idx="1">
+              <a:schemeClr val="accent1"/>
+            </a:fillRef>
+            <a:effectRef idx="0">
+              <a:schemeClr val="accent1"/>
+            </a:effectRef>
+            <a:fontRef idx="minor">
+              <a:schemeClr val="lt1"/>
+            </a:fontRef>
+          </p:style>
+          <p:txBody>
+            <a:bodyPr rtlCol="0" anchor="ctr"/>
+            <a:lstStyle/>
+            <a:p>
+              <a:pPr algn="ctr"/>
+              <a:endParaRPr lang="en-US"/>
+            </a:p>
+          </p:txBody>
+        </p:sp>
+        <p:sp>
+          <p:nvSpPr>
+            <p:cNvPr id="540" name="Terminator 539">
+              <a:extLst>
+                <a:ext uri="{FF2B5EF4-FFF2-40B4-BE49-F238E27FC236}">
+                  <a16:creationId xmlns:a16="http://schemas.microsoft.com/office/drawing/2014/main" id="{786AC2C6-591B-3241-B0CA-5D66AA67805F}"/>
+                </a:ext>
+              </a:extLst>
+            </p:cNvPr>
+            <p:cNvSpPr/>
+            <p:nvPr/>
+          </p:nvSpPr>
+          <p:spPr>
+            <a:xfrm rot="3683302">
+              <a:off x="10187571" y="3543492"/>
+              <a:ext cx="452919" cy="149463"/>
+            </a:xfrm>
+            <a:prstGeom prst="flowChartTerminator">
+              <a:avLst/>
+            </a:prstGeom>
+            <a:solidFill>
+              <a:schemeClr val="tx1"/>
+            </a:solidFill>
+            <a:ln w="28575">
+              <a:solidFill>
+                <a:schemeClr val="bg1"/>
+              </a:solidFill>
+            </a:ln>
+          </p:spPr>
+          <p:style>
+            <a:lnRef idx="2">
+              <a:schemeClr val="accent1">
+                <a:shade val="50000"/>
+              </a:schemeClr>
+            </a:lnRef>
+            <a:fillRef idx="1">
+              <a:schemeClr val="accent1"/>
+            </a:fillRef>
+            <a:effectRef idx="0">
+              <a:schemeClr val="accent1"/>
+            </a:effectRef>
+            <a:fontRef idx="minor">
+              <a:schemeClr val="lt1"/>
+            </a:fontRef>
+          </p:style>
+          <p:txBody>
+            <a:bodyPr rtlCol="0" anchor="ctr"/>
+            <a:lstStyle/>
+            <a:p>
+              <a:pPr algn="ctr"/>
+              <a:endParaRPr lang="en-US"/>
+            </a:p>
+          </p:txBody>
+        </p:sp>
+        <p:sp>
+          <p:nvSpPr>
+            <p:cNvPr id="541" name="Delay 540">
+              <a:extLst>
+                <a:ext uri="{FF2B5EF4-FFF2-40B4-BE49-F238E27FC236}">
+                  <a16:creationId xmlns:a16="http://schemas.microsoft.com/office/drawing/2014/main" id="{37D2DA66-A24E-E240-8C20-833386F126EC}"/>
+                </a:ext>
+              </a:extLst>
+            </p:cNvPr>
+            <p:cNvSpPr/>
+            <p:nvPr/>
+          </p:nvSpPr>
+          <p:spPr>
+            <a:xfrm rot="16200000">
+              <a:off x="9886099" y="3369205"/>
+              <a:ext cx="514626" cy="406636"/>
+            </a:xfrm>
+            <a:prstGeom prst="flowChartDelay">
+              <a:avLst/>
+            </a:prstGeom>
+            <a:solidFill>
+              <a:schemeClr val="tx1"/>
+            </a:solidFill>
+            <a:ln w="38100">
+              <a:solidFill>
+                <a:schemeClr val="bg1"/>
+              </a:solidFill>
+            </a:ln>
+          </p:spPr>
+          <p:style>
+            <a:lnRef idx="2">
+              <a:schemeClr val="accent1">
+                <a:shade val="50000"/>
+              </a:schemeClr>
+            </a:lnRef>
+            <a:fillRef idx="1">
+              <a:schemeClr val="accent1"/>
+            </a:fillRef>
+            <a:effectRef idx="0">
+              <a:schemeClr val="accent1"/>
+            </a:effectRef>
+            <a:fontRef idx="minor">
+              <a:schemeClr val="lt1"/>
+            </a:fontRef>
+          </p:style>
+          <p:txBody>
+            <a:bodyPr rtlCol="0" anchor="ctr"/>
+            <a:lstStyle/>
+            <a:p>
+              <a:pPr algn="ctr"/>
+              <a:endParaRPr lang="en-US" dirty="0"/>
+            </a:p>
+          </p:txBody>
+        </p:sp>
+        <p:sp>
+          <p:nvSpPr>
+            <p:cNvPr id="542" name="Oval 541">
+              <a:extLst>
+                <a:ext uri="{FF2B5EF4-FFF2-40B4-BE49-F238E27FC236}">
+                  <a16:creationId xmlns:a16="http://schemas.microsoft.com/office/drawing/2014/main" id="{5253E6BA-99DC-A44F-8EE8-8703B01A5D82}"/>
+                </a:ext>
+              </a:extLst>
+            </p:cNvPr>
+            <p:cNvSpPr/>
+            <p:nvPr/>
+          </p:nvSpPr>
+          <p:spPr>
+            <a:xfrm>
+              <a:off x="9986505" y="3088909"/>
+              <a:ext cx="316756" cy="316756"/>
+            </a:xfrm>
+            <a:prstGeom prst="ellipse">
+              <a:avLst/>
+            </a:prstGeom>
+            <a:solidFill>
+              <a:schemeClr val="tx1"/>
+            </a:solidFill>
+            <a:ln w="38100">
+              <a:solidFill>
+                <a:schemeClr val="bg1"/>
+              </a:solidFill>
+            </a:ln>
+          </p:spPr>
+          <p:style>
+            <a:lnRef idx="2">
+              <a:schemeClr val="accent1">
+                <a:shade val="50000"/>
+              </a:schemeClr>
+            </a:lnRef>
+            <a:fillRef idx="1">
+              <a:schemeClr val="accent1"/>
+            </a:fillRef>
+            <a:effectRef idx="0">
+              <a:schemeClr val="accent1"/>
+            </a:effectRef>
+            <a:fontRef idx="minor">
+              <a:schemeClr val="lt1"/>
+            </a:fontRef>
+          </p:style>
+          <p:txBody>
+            <a:bodyPr rtlCol="0" anchor="ctr"/>
+            <a:lstStyle/>
+            <a:p>
+              <a:pPr algn="ctr"/>
+              <a:endParaRPr lang="en-US"/>
+            </a:p>
+          </p:txBody>
+        </p:sp>
+      </p:grpSp>
+      <p:sp>
+        <p:nvSpPr>
+          <p:cNvPr id="4" name="Moon 3">
+            <a:extLst>
+              <a:ext uri="{FF2B5EF4-FFF2-40B4-BE49-F238E27FC236}">
+                <a16:creationId xmlns:a16="http://schemas.microsoft.com/office/drawing/2014/main" id="{ED463851-C602-7942-826F-6E7959971A51}"/>
+              </a:ext>
+            </a:extLst>
+          </p:cNvPr>
+          <p:cNvSpPr/>
+          <p:nvPr/>
+        </p:nvSpPr>
+        <p:spPr>
+          <a:xfrm rot="5400000" flipV="1">
+            <a:off x="10517324" y="3331487"/>
+            <a:ext cx="188413" cy="544289"/>
+          </a:xfrm>
+          <a:custGeom>
+            <a:avLst/>
+            <a:gdLst>
+              <a:gd name="connsiteX0" fmla="*/ 400181 w 400181"/>
+              <a:gd name="connsiteY0" fmla="*/ 800362 h 800362"/>
+              <a:gd name="connsiteX1" fmla="*/ 0 w 400181"/>
+              <a:gd name="connsiteY1" fmla="*/ 400181 h 800362"/>
+              <a:gd name="connsiteX2" fmla="*/ 400181 w 400181"/>
+              <a:gd name="connsiteY2" fmla="*/ 0 h 800362"/>
+              <a:gd name="connsiteX3" fmla="*/ 200091 w 400181"/>
+              <a:gd name="connsiteY3" fmla="*/ 400181 h 800362"/>
+              <a:gd name="connsiteX4" fmla="*/ 400181 w 400181"/>
+              <a:gd name="connsiteY4" fmla="*/ 800362 h 800362"/>
+              <a:gd name="connsiteX0" fmla="*/ 400181 w 555995"/>
+              <a:gd name="connsiteY0" fmla="*/ 800362 h 800362"/>
+              <a:gd name="connsiteX1" fmla="*/ 0 w 555995"/>
+              <a:gd name="connsiteY1" fmla="*/ 400181 h 800362"/>
+              <a:gd name="connsiteX2" fmla="*/ 400181 w 555995"/>
+              <a:gd name="connsiteY2" fmla="*/ 0 h 800362"/>
+              <a:gd name="connsiteX3" fmla="*/ 555995 w 555995"/>
+              <a:gd name="connsiteY3" fmla="*/ 383755 h 800362"/>
+              <a:gd name="connsiteX4" fmla="*/ 400181 w 555995"/>
+              <a:gd name="connsiteY4" fmla="*/ 800362 h 800362"/>
+              <a:gd name="connsiteX0" fmla="*/ 137872 w 293686"/>
+              <a:gd name="connsiteY0" fmla="*/ 800362 h 800362"/>
+              <a:gd name="connsiteX1" fmla="*/ 27890 w 293686"/>
+              <a:gd name="connsiteY1" fmla="*/ 405656 h 800362"/>
+              <a:gd name="connsiteX2" fmla="*/ 137872 w 293686"/>
+              <a:gd name="connsiteY2" fmla="*/ 0 h 800362"/>
+              <a:gd name="connsiteX3" fmla="*/ 293686 w 293686"/>
+              <a:gd name="connsiteY3" fmla="*/ 383755 h 800362"/>
+              <a:gd name="connsiteX4" fmla="*/ 137872 w 293686"/>
+              <a:gd name="connsiteY4" fmla="*/ 800362 h 800362"/>
+              <a:gd name="connsiteX0" fmla="*/ 137872 w 293686"/>
+              <a:gd name="connsiteY0" fmla="*/ 800362 h 800362"/>
+              <a:gd name="connsiteX1" fmla="*/ 27890 w 293686"/>
+              <a:gd name="connsiteY1" fmla="*/ 405656 h 800362"/>
+              <a:gd name="connsiteX2" fmla="*/ 137872 w 293686"/>
+              <a:gd name="connsiteY2" fmla="*/ 0 h 800362"/>
+              <a:gd name="connsiteX3" fmla="*/ 293686 w 293686"/>
+              <a:gd name="connsiteY3" fmla="*/ 383755 h 800362"/>
+              <a:gd name="connsiteX4" fmla="*/ 137872 w 293686"/>
+              <a:gd name="connsiteY4" fmla="*/ 800362 h 800362"/>
+              <a:gd name="connsiteX0" fmla="*/ 137872 w 293686"/>
+              <a:gd name="connsiteY0" fmla="*/ 800362 h 800362"/>
+              <a:gd name="connsiteX1" fmla="*/ 27890 w 293686"/>
+              <a:gd name="connsiteY1" fmla="*/ 405656 h 800362"/>
+              <a:gd name="connsiteX2" fmla="*/ 137872 w 293686"/>
+              <a:gd name="connsiteY2" fmla="*/ 0 h 800362"/>
+              <a:gd name="connsiteX3" fmla="*/ 293686 w 293686"/>
+              <a:gd name="connsiteY3" fmla="*/ 383755 h 800362"/>
+              <a:gd name="connsiteX4" fmla="*/ 137872 w 293686"/>
+              <a:gd name="connsiteY4" fmla="*/ 800362 h 800362"/>
+              <a:gd name="connsiteX0" fmla="*/ 137872 w 293686"/>
+              <a:gd name="connsiteY0" fmla="*/ 800362 h 800362"/>
+              <a:gd name="connsiteX1" fmla="*/ 27890 w 293686"/>
+              <a:gd name="connsiteY1" fmla="*/ 405656 h 800362"/>
+              <a:gd name="connsiteX2" fmla="*/ 137872 w 293686"/>
+              <a:gd name="connsiteY2" fmla="*/ 0 h 800362"/>
+              <a:gd name="connsiteX3" fmla="*/ 293686 w 293686"/>
+              <a:gd name="connsiteY3" fmla="*/ 383755 h 800362"/>
+              <a:gd name="connsiteX4" fmla="*/ 137872 w 293686"/>
+              <a:gd name="connsiteY4" fmla="*/ 800362 h 800362"/>
+              <a:gd name="connsiteX0" fmla="*/ 111565 w 267379"/>
+              <a:gd name="connsiteY0" fmla="*/ 800362 h 800362"/>
+              <a:gd name="connsiteX1" fmla="*/ 1583 w 267379"/>
+              <a:gd name="connsiteY1" fmla="*/ 405656 h 800362"/>
+              <a:gd name="connsiteX2" fmla="*/ 111565 w 267379"/>
+              <a:gd name="connsiteY2" fmla="*/ 0 h 800362"/>
+              <a:gd name="connsiteX3" fmla="*/ 267379 w 267379"/>
+              <a:gd name="connsiteY3" fmla="*/ 383755 h 800362"/>
+              <a:gd name="connsiteX4" fmla="*/ 111565 w 267379"/>
+              <a:gd name="connsiteY4" fmla="*/ 800362 h 800362"/>
+              <a:gd name="connsiteX0" fmla="*/ 121242 w 277056"/>
+              <a:gd name="connsiteY0" fmla="*/ 800362 h 800362"/>
+              <a:gd name="connsiteX1" fmla="*/ 309 w 277056"/>
+              <a:gd name="connsiteY1" fmla="*/ 427558 h 800362"/>
+              <a:gd name="connsiteX2" fmla="*/ 121242 w 277056"/>
+              <a:gd name="connsiteY2" fmla="*/ 0 h 800362"/>
+              <a:gd name="connsiteX3" fmla="*/ 277056 w 277056"/>
+              <a:gd name="connsiteY3" fmla="*/ 383755 h 800362"/>
+              <a:gd name="connsiteX4" fmla="*/ 121242 w 277056"/>
+              <a:gd name="connsiteY4" fmla="*/ 800362 h 800362"/>
+              <a:gd name="connsiteX0" fmla="*/ 121242 w 277056"/>
+              <a:gd name="connsiteY0" fmla="*/ 800362 h 800362"/>
+              <a:gd name="connsiteX1" fmla="*/ 309 w 277056"/>
+              <a:gd name="connsiteY1" fmla="*/ 427558 h 800362"/>
+              <a:gd name="connsiteX2" fmla="*/ 121242 w 277056"/>
+              <a:gd name="connsiteY2" fmla="*/ 0 h 800362"/>
+              <a:gd name="connsiteX3" fmla="*/ 277056 w 277056"/>
+              <a:gd name="connsiteY3" fmla="*/ 389231 h 800362"/>
+              <a:gd name="connsiteX4" fmla="*/ 121242 w 277056"/>
+              <a:gd name="connsiteY4" fmla="*/ 800362 h 800362"/>
+            </a:gdLst>
+            <a:ahLst/>
+            <a:cxnLst>
+              <a:cxn ang="0">
+                <a:pos x="connsiteX0" y="connsiteY0"/>
+              </a:cxn>
+              <a:cxn ang="0">
+                <a:pos x="connsiteX1" y="connsiteY1"/>
+              </a:cxn>
+              <a:cxn ang="0">
+                <a:pos x="connsiteX2" y="connsiteY2"/>
+              </a:cxn>
+              <a:cxn ang="0">
+                <a:pos x="connsiteX3" y="connsiteY3"/>
+              </a:cxn>
+              <a:cxn ang="0">
+                <a:pos x="connsiteX4" y="connsiteY4"/>
+              </a:cxn>
+            </a:cxnLst>
+            <a:rect l="l" t="t" r="r" b="b"/>
+            <a:pathLst>
+              <a:path w="277056" h="800362">
+                <a:moveTo>
+                  <a:pt x="121242" y="800362"/>
+                </a:moveTo>
+                <a:cubicBezTo>
+                  <a:pt x="48065" y="647050"/>
+                  <a:pt x="309" y="648572"/>
+                  <a:pt x="309" y="427558"/>
+                </a:cubicBezTo>
+                <a:cubicBezTo>
+                  <a:pt x="309" y="206544"/>
+                  <a:pt x="-12165" y="120460"/>
+                  <a:pt x="121242" y="0"/>
+                </a:cubicBezTo>
+                <a:cubicBezTo>
+                  <a:pt x="186923" y="50666"/>
+                  <a:pt x="277056" y="231781"/>
+                  <a:pt x="277056" y="389231"/>
+                </a:cubicBezTo>
+                <a:cubicBezTo>
+                  <a:pt x="277056" y="546681"/>
+                  <a:pt x="192400" y="585432"/>
+                  <a:pt x="121242" y="800362"/>
+                </a:cubicBezTo>
+                <a:close/>
+              </a:path>
+            </a:pathLst>
+          </a:custGeom>
+          <a:solidFill>
+            <a:schemeClr val="bg1"/>
+          </a:solidFill>
+          <a:ln w="57150">
+            <a:solidFill>
+              <a:schemeClr val="tx1"/>
+            </a:solidFill>
+          </a:ln>
+        </p:spPr>
+        <p:style>
+          <a:lnRef idx="2">
+            <a:schemeClr val="accent1">
+              <a:shade val="50000"/>
+            </a:schemeClr>
+          </a:lnRef>
+          <a:fillRef idx="1">
+            <a:schemeClr val="accent1"/>
+          </a:fillRef>
+          <a:effectRef idx="0">
+            <a:schemeClr val="accent1"/>
+          </a:effectRef>
+          <a:fontRef idx="minor">
+            <a:schemeClr val="lt1"/>
+          </a:fontRef>
+        </p:style>
+        <p:txBody>
+          <a:bodyPr rtlCol="0" anchor="ctr"/>
+          <a:lstStyle/>
+          <a:p>
+            <a:pPr algn="ctr"/>
+            <a:endParaRPr lang="en-US"/>
+          </a:p>
+        </p:txBody>
+      </p:sp>
+      <p:sp>
+        <p:nvSpPr>
+          <p:cNvPr id="543" name="Moon 3">
+            <a:extLst>
+              <a:ext uri="{FF2B5EF4-FFF2-40B4-BE49-F238E27FC236}">
+                <a16:creationId xmlns:a16="http://schemas.microsoft.com/office/drawing/2014/main" id="{0F282097-2EC0-054F-8D3A-36981066700D}"/>
+              </a:ext>
+            </a:extLst>
+          </p:cNvPr>
+          <p:cNvSpPr/>
+          <p:nvPr/>
+        </p:nvSpPr>
+        <p:spPr>
+          <a:xfrm rot="16200000" flipH="1" flipV="1">
+            <a:off x="9980810" y="3331487"/>
+            <a:ext cx="188413" cy="544289"/>
+          </a:xfrm>
+          <a:custGeom>
+            <a:avLst/>
+            <a:gdLst>
+              <a:gd name="connsiteX0" fmla="*/ 400181 w 400181"/>
+              <a:gd name="connsiteY0" fmla="*/ 800362 h 800362"/>
+              <a:gd name="connsiteX1" fmla="*/ 0 w 400181"/>
+              <a:gd name="connsiteY1" fmla="*/ 400181 h 800362"/>
+              <a:gd name="connsiteX2" fmla="*/ 400181 w 400181"/>
+              <a:gd name="connsiteY2" fmla="*/ 0 h 800362"/>
+              <a:gd name="connsiteX3" fmla="*/ 200091 w 400181"/>
+              <a:gd name="connsiteY3" fmla="*/ 400181 h 800362"/>
+              <a:gd name="connsiteX4" fmla="*/ 400181 w 400181"/>
+              <a:gd name="connsiteY4" fmla="*/ 800362 h 800362"/>
+              <a:gd name="connsiteX0" fmla="*/ 400181 w 555995"/>
+              <a:gd name="connsiteY0" fmla="*/ 800362 h 800362"/>
+              <a:gd name="connsiteX1" fmla="*/ 0 w 555995"/>
+              <a:gd name="connsiteY1" fmla="*/ 400181 h 800362"/>
+              <a:gd name="connsiteX2" fmla="*/ 400181 w 555995"/>
+              <a:gd name="connsiteY2" fmla="*/ 0 h 800362"/>
+              <a:gd name="connsiteX3" fmla="*/ 555995 w 555995"/>
+              <a:gd name="connsiteY3" fmla="*/ 383755 h 800362"/>
+              <a:gd name="connsiteX4" fmla="*/ 400181 w 555995"/>
+              <a:gd name="connsiteY4" fmla="*/ 800362 h 800362"/>
+              <a:gd name="connsiteX0" fmla="*/ 137872 w 293686"/>
+              <a:gd name="connsiteY0" fmla="*/ 800362 h 800362"/>
+              <a:gd name="connsiteX1" fmla="*/ 27890 w 293686"/>
+              <a:gd name="connsiteY1" fmla="*/ 405656 h 800362"/>
+              <a:gd name="connsiteX2" fmla="*/ 137872 w 293686"/>
+              <a:gd name="connsiteY2" fmla="*/ 0 h 800362"/>
+              <a:gd name="connsiteX3" fmla="*/ 293686 w 293686"/>
+              <a:gd name="connsiteY3" fmla="*/ 383755 h 800362"/>
+              <a:gd name="connsiteX4" fmla="*/ 137872 w 293686"/>
+              <a:gd name="connsiteY4" fmla="*/ 800362 h 800362"/>
+              <a:gd name="connsiteX0" fmla="*/ 137872 w 293686"/>
+              <a:gd name="connsiteY0" fmla="*/ 800362 h 800362"/>
+              <a:gd name="connsiteX1" fmla="*/ 27890 w 293686"/>
+              <a:gd name="connsiteY1" fmla="*/ 405656 h 800362"/>
+              <a:gd name="connsiteX2" fmla="*/ 137872 w 293686"/>
+              <a:gd name="connsiteY2" fmla="*/ 0 h 800362"/>
+              <a:gd name="connsiteX3" fmla="*/ 293686 w 293686"/>
+              <a:gd name="connsiteY3" fmla="*/ 383755 h 800362"/>
+              <a:gd name="connsiteX4" fmla="*/ 137872 w 293686"/>
+              <a:gd name="connsiteY4" fmla="*/ 800362 h 800362"/>
+              <a:gd name="connsiteX0" fmla="*/ 137872 w 293686"/>
+              <a:gd name="connsiteY0" fmla="*/ 800362 h 800362"/>
+              <a:gd name="connsiteX1" fmla="*/ 27890 w 293686"/>
+              <a:gd name="connsiteY1" fmla="*/ 405656 h 800362"/>
+              <a:gd name="connsiteX2" fmla="*/ 137872 w 293686"/>
+              <a:gd name="connsiteY2" fmla="*/ 0 h 800362"/>
+              <a:gd name="connsiteX3" fmla="*/ 293686 w 293686"/>
+              <a:gd name="connsiteY3" fmla="*/ 383755 h 800362"/>
+              <a:gd name="connsiteX4" fmla="*/ 137872 w 293686"/>
+              <a:gd name="connsiteY4" fmla="*/ 800362 h 800362"/>
+              <a:gd name="connsiteX0" fmla="*/ 137872 w 293686"/>
+              <a:gd name="connsiteY0" fmla="*/ 800362 h 800362"/>
+              <a:gd name="connsiteX1" fmla="*/ 27890 w 293686"/>
+              <a:gd name="connsiteY1" fmla="*/ 405656 h 800362"/>
+              <a:gd name="connsiteX2" fmla="*/ 137872 w 293686"/>
+              <a:gd name="connsiteY2" fmla="*/ 0 h 800362"/>
+              <a:gd name="connsiteX3" fmla="*/ 293686 w 293686"/>
+              <a:gd name="connsiteY3" fmla="*/ 383755 h 800362"/>
+              <a:gd name="connsiteX4" fmla="*/ 137872 w 293686"/>
+              <a:gd name="connsiteY4" fmla="*/ 800362 h 800362"/>
+              <a:gd name="connsiteX0" fmla="*/ 111565 w 267379"/>
+              <a:gd name="connsiteY0" fmla="*/ 800362 h 800362"/>
+              <a:gd name="connsiteX1" fmla="*/ 1583 w 267379"/>
+              <a:gd name="connsiteY1" fmla="*/ 405656 h 800362"/>
+              <a:gd name="connsiteX2" fmla="*/ 111565 w 267379"/>
+              <a:gd name="connsiteY2" fmla="*/ 0 h 800362"/>
+              <a:gd name="connsiteX3" fmla="*/ 267379 w 267379"/>
+              <a:gd name="connsiteY3" fmla="*/ 383755 h 800362"/>
+              <a:gd name="connsiteX4" fmla="*/ 111565 w 267379"/>
+              <a:gd name="connsiteY4" fmla="*/ 800362 h 800362"/>
+              <a:gd name="connsiteX0" fmla="*/ 121242 w 277056"/>
+              <a:gd name="connsiteY0" fmla="*/ 800362 h 800362"/>
+              <a:gd name="connsiteX1" fmla="*/ 309 w 277056"/>
+              <a:gd name="connsiteY1" fmla="*/ 427558 h 800362"/>
+              <a:gd name="connsiteX2" fmla="*/ 121242 w 277056"/>
+              <a:gd name="connsiteY2" fmla="*/ 0 h 800362"/>
+              <a:gd name="connsiteX3" fmla="*/ 277056 w 277056"/>
+              <a:gd name="connsiteY3" fmla="*/ 383755 h 800362"/>
+              <a:gd name="connsiteX4" fmla="*/ 121242 w 277056"/>
+              <a:gd name="connsiteY4" fmla="*/ 800362 h 800362"/>
+              <a:gd name="connsiteX0" fmla="*/ 121242 w 277056"/>
+              <a:gd name="connsiteY0" fmla="*/ 800362 h 800362"/>
+              <a:gd name="connsiteX1" fmla="*/ 309 w 277056"/>
+              <a:gd name="connsiteY1" fmla="*/ 427558 h 800362"/>
+              <a:gd name="connsiteX2" fmla="*/ 121242 w 277056"/>
+              <a:gd name="connsiteY2" fmla="*/ 0 h 800362"/>
+              <a:gd name="connsiteX3" fmla="*/ 277056 w 277056"/>
+              <a:gd name="connsiteY3" fmla="*/ 389231 h 800362"/>
+              <a:gd name="connsiteX4" fmla="*/ 121242 w 277056"/>
+              <a:gd name="connsiteY4" fmla="*/ 800362 h 800362"/>
+            </a:gdLst>
+            <a:ahLst/>
+            <a:cxnLst>
+              <a:cxn ang="0">
+                <a:pos x="connsiteX0" y="connsiteY0"/>
+              </a:cxn>
+              <a:cxn ang="0">
+                <a:pos x="connsiteX1" y="connsiteY1"/>
+              </a:cxn>
+              <a:cxn ang="0">
+                <a:pos x="connsiteX2" y="connsiteY2"/>
+              </a:cxn>
+              <a:cxn ang="0">
+                <a:pos x="connsiteX3" y="connsiteY3"/>
+              </a:cxn>
+              <a:cxn ang="0">
+                <a:pos x="connsiteX4" y="connsiteY4"/>
+              </a:cxn>
+            </a:cxnLst>
+            <a:rect l="l" t="t" r="r" b="b"/>
+            <a:pathLst>
+              <a:path w="277056" h="800362">
+                <a:moveTo>
+                  <a:pt x="121242" y="800362"/>
+                </a:moveTo>
+                <a:cubicBezTo>
+                  <a:pt x="48065" y="647050"/>
+                  <a:pt x="309" y="648572"/>
+                  <a:pt x="309" y="427558"/>
+                </a:cubicBezTo>
+                <a:cubicBezTo>
+                  <a:pt x="309" y="206544"/>
+                  <a:pt x="-12165" y="120460"/>
+                  <a:pt x="121242" y="0"/>
+                </a:cubicBezTo>
+                <a:cubicBezTo>
+                  <a:pt x="186923" y="50666"/>
+                  <a:pt x="277056" y="231781"/>
+                  <a:pt x="277056" y="389231"/>
+                </a:cubicBezTo>
+                <a:cubicBezTo>
+                  <a:pt x="277056" y="546681"/>
+                  <a:pt x="192400" y="585432"/>
+                  <a:pt x="121242" y="800362"/>
+                </a:cubicBezTo>
+                <a:close/>
+              </a:path>
+            </a:pathLst>
+          </a:custGeom>
+          <a:solidFill>
+            <a:schemeClr val="bg1"/>
+          </a:solidFill>
+          <a:ln w="57150">
+            <a:solidFill>
+              <a:schemeClr val="tx1"/>
+            </a:solidFill>
+          </a:ln>
+        </p:spPr>
+        <p:style>
+          <a:lnRef idx="2">
+            <a:schemeClr val="accent1">
+              <a:shade val="50000"/>
+            </a:schemeClr>
+          </a:lnRef>
+          <a:fillRef idx="1">
+            <a:schemeClr val="accent1"/>
+          </a:fillRef>
+          <a:effectRef idx="0">
+            <a:schemeClr val="accent1"/>
+          </a:effectRef>
+          <a:fontRef idx="minor">
+            <a:schemeClr val="lt1"/>
+          </a:fontRef>
+        </p:style>
+        <p:txBody>
+          <a:bodyPr rtlCol="0" anchor="ctr"/>
+          <a:lstStyle/>
+          <a:p>
+            <a:pPr algn="ctr"/>
+            <a:endParaRPr lang="en-US"/>
+          </a:p>
+        </p:txBody>
+      </p:sp>
+      <p:sp>
+        <p:nvSpPr>
+          <p:cNvPr id="544" name="Oval 543">
+            <a:extLst>
+              <a:ext uri="{FF2B5EF4-FFF2-40B4-BE49-F238E27FC236}">
+                <a16:creationId xmlns:a16="http://schemas.microsoft.com/office/drawing/2014/main" id="{B0D7CD39-8FFC-4C4D-AEA5-3C9885DAFF77}"/>
+              </a:ext>
+            </a:extLst>
+          </p:cNvPr>
+          <p:cNvSpPr/>
+          <p:nvPr/>
+        </p:nvSpPr>
+        <p:spPr>
+          <a:xfrm>
+            <a:off x="10011783" y="3497202"/>
+            <a:ext cx="164092" cy="164092"/>
+          </a:xfrm>
+          <a:prstGeom prst="ellipse">
+            <a:avLst/>
+          </a:prstGeom>
+          <a:solidFill>
+            <a:schemeClr val="tx1"/>
+          </a:solidFill>
+          <a:ln w="38100">
+            <a:noFill/>
+          </a:ln>
+        </p:spPr>
+        <p:style>
+          <a:lnRef idx="2">
+            <a:schemeClr val="accent1">
+              <a:shade val="50000"/>
+            </a:schemeClr>
+          </a:lnRef>
+          <a:fillRef idx="1">
+            <a:schemeClr val="accent1"/>
+          </a:fillRef>
+          <a:effectRef idx="0">
+            <a:schemeClr val="accent1"/>
+          </a:effectRef>
+          <a:fontRef idx="minor">
+            <a:schemeClr val="lt1"/>
+          </a:fontRef>
+        </p:style>
+        <p:txBody>
+          <a:bodyPr rtlCol="0" anchor="ctr"/>
+          <a:lstStyle/>
+          <a:p>
+            <a:pPr algn="ctr"/>
+            <a:endParaRPr lang="en-US"/>
+          </a:p>
+        </p:txBody>
+      </p:sp>
+      <p:sp>
+        <p:nvSpPr>
+          <p:cNvPr id="545" name="Oval 544">
+            <a:extLst>
+              <a:ext uri="{FF2B5EF4-FFF2-40B4-BE49-F238E27FC236}">
+                <a16:creationId xmlns:a16="http://schemas.microsoft.com/office/drawing/2014/main" id="{619A9812-7CE8-E14F-A211-FFD9A0938487}"/>
+              </a:ext>
+            </a:extLst>
+          </p:cNvPr>
+          <p:cNvSpPr/>
+          <p:nvPr/>
+        </p:nvSpPr>
+        <p:spPr>
+          <a:xfrm>
+            <a:off x="10510672" y="3494986"/>
+            <a:ext cx="164092" cy="164092"/>
+          </a:xfrm>
+          <a:prstGeom prst="ellipse">
+            <a:avLst/>
+          </a:prstGeom>
+          <a:solidFill>
+            <a:schemeClr val="tx1"/>
+          </a:solidFill>
+          <a:ln w="38100">
+            <a:noFill/>
+          </a:ln>
+        </p:spPr>
+        <p:style>
+          <a:lnRef idx="2">
+            <a:schemeClr val="accent1">
+              <a:shade val="50000"/>
+            </a:schemeClr>
+          </a:lnRef>
+          <a:fillRef idx="1">
+            <a:schemeClr val="accent1"/>
+          </a:fillRef>
+          <a:effectRef idx="0">
+            <a:schemeClr val="accent1"/>
+          </a:effectRef>
+          <a:fontRef idx="minor">
+            <a:schemeClr val="lt1"/>
+          </a:fontRef>
+        </p:style>
+        <p:txBody>
+          <a:bodyPr rtlCol="0" anchor="ctr"/>
+          <a:lstStyle/>
+          <a:p>
+            <a:pPr algn="ctr"/>
+            <a:endParaRPr lang="en-US"/>
+          </a:p>
+        </p:txBody>
+      </p:sp>
     </p:spTree>
     <p:extLst>
       <p:ext uri="{BB962C8B-B14F-4D97-AF65-F5344CB8AC3E}">

</xml_diff>

<commit_message>
adds logo to papers
</commit_message>
<xml_diff>
--- a/logos/logos.pptx
+++ b/logos/logos.pptx
@@ -30955,8 +30955,8 @@
         </p:nvSpPr>
         <p:spPr>
           <a:xfrm>
-            <a:off x="10579585" y="5614670"/>
-            <a:ext cx="1201530" cy="803966"/>
+            <a:off x="10612213" y="5466251"/>
+            <a:ext cx="1136274" cy="1100804"/>
           </a:xfrm>
           <a:prstGeom prst="roundRect">
             <a:avLst>
@@ -30966,8 +30966,10 @@
           <a:solidFill>
             <a:schemeClr val="tx1"/>
           </a:solidFill>
-          <a:ln>
-            <a:noFill/>
+          <a:ln w="76200">
+            <a:solidFill>
+              <a:schemeClr val="tx1"/>
+            </a:solidFill>
           </a:ln>
         </p:spPr>
         <p:style>
@@ -31019,7 +31021,9 @@
             <a:schemeClr val="bg1"/>
           </a:solidFill>
           <a:ln>
-            <a:noFill/>
+            <a:solidFill>
+              <a:schemeClr val="bg1"/>
+            </a:solidFill>
           </a:ln>
         </p:spPr>
         <p:style>
@@ -31047,6 +31051,47 @@
           </a:p>
         </p:txBody>
       </p:sp>
+      <p:pic>
+        <p:nvPicPr>
+          <p:cNvPr id="22" name="Picture 21">
+            <a:extLst>
+              <a:ext uri="{FF2B5EF4-FFF2-40B4-BE49-F238E27FC236}">
+                <a16:creationId xmlns:a16="http://schemas.microsoft.com/office/drawing/2014/main" id="{90588753-0E1F-AB40-A568-94E37677BECF}"/>
+              </a:ext>
+            </a:extLst>
+          </p:cNvPr>
+          <p:cNvPicPr>
+            <a:picLocks noChangeAspect="1"/>
+          </p:cNvPicPr>
+          <p:nvPr/>
+        </p:nvPicPr>
+        <p:blipFill>
+          <a:blip r:embed="rId15">
+            <a:clrChange>
+              <a:clrFrom>
+                <a:srgbClr val="FFFFFF"/>
+              </a:clrFrom>
+              <a:clrTo>
+                <a:srgbClr val="FFFFFF">
+                  <a:alpha val="0"/>
+                </a:srgbClr>
+              </a:clrTo>
+            </a:clrChange>
+          </a:blip>
+          <a:stretch>
+            <a:fillRect/>
+          </a:stretch>
+        </p:blipFill>
+        <p:spPr>
+          <a:xfrm>
+            <a:off x="12211041" y="4030799"/>
+            <a:ext cx="2590800" cy="2603500"/>
+          </a:xfrm>
+          <a:prstGeom prst="rect">
+            <a:avLst/>
+          </a:prstGeom>
+        </p:spPr>
+      </p:pic>
     </p:spTree>
     <p:extLst>
       <p:ext uri="{BB962C8B-B14F-4D97-AF65-F5344CB8AC3E}">

</xml_diff>

<commit_message>
places logos on the right
</commit_message>
<xml_diff>
--- a/logos/logos.pptx
+++ b/logos/logos.pptx
@@ -261,7 +261,7 @@
           <a:p>
             <a:fld id="{16F93EB0-79FE-3A48-9677-781C433206CF}" type="datetimeFigureOut">
               <a:rPr lang="en-US" smtClean="0"/>
-              <a:t>8/30/21</a:t>
+              <a:t>9/3/21</a:t>
             </a:fld>
             <a:endParaRPr lang="en-US"/>
           </a:p>
@@ -461,7 +461,7 @@
           <a:p>
             <a:fld id="{16F93EB0-79FE-3A48-9677-781C433206CF}" type="datetimeFigureOut">
               <a:rPr lang="en-US" smtClean="0"/>
-              <a:t>8/30/21</a:t>
+              <a:t>9/3/21</a:t>
             </a:fld>
             <a:endParaRPr lang="en-US"/>
           </a:p>
@@ -671,7 +671,7 @@
           <a:p>
             <a:fld id="{16F93EB0-79FE-3A48-9677-781C433206CF}" type="datetimeFigureOut">
               <a:rPr lang="en-US" smtClean="0"/>
-              <a:t>8/30/21</a:t>
+              <a:t>9/3/21</a:t>
             </a:fld>
             <a:endParaRPr lang="en-US"/>
           </a:p>
@@ -871,7 +871,7 @@
           <a:p>
             <a:fld id="{16F93EB0-79FE-3A48-9677-781C433206CF}" type="datetimeFigureOut">
               <a:rPr lang="en-US" smtClean="0"/>
-              <a:t>8/30/21</a:t>
+              <a:t>9/3/21</a:t>
             </a:fld>
             <a:endParaRPr lang="en-US"/>
           </a:p>
@@ -1147,7 +1147,7 @@
           <a:p>
             <a:fld id="{16F93EB0-79FE-3A48-9677-781C433206CF}" type="datetimeFigureOut">
               <a:rPr lang="en-US" smtClean="0"/>
-              <a:t>8/30/21</a:t>
+              <a:t>9/3/21</a:t>
             </a:fld>
             <a:endParaRPr lang="en-US"/>
           </a:p>
@@ -1415,7 +1415,7 @@
           <a:p>
             <a:fld id="{16F93EB0-79FE-3A48-9677-781C433206CF}" type="datetimeFigureOut">
               <a:rPr lang="en-US" smtClean="0"/>
-              <a:t>8/30/21</a:t>
+              <a:t>9/3/21</a:t>
             </a:fld>
             <a:endParaRPr lang="en-US"/>
           </a:p>
@@ -1830,7 +1830,7 @@
           <a:p>
             <a:fld id="{16F93EB0-79FE-3A48-9677-781C433206CF}" type="datetimeFigureOut">
               <a:rPr lang="en-US" smtClean="0"/>
-              <a:t>8/30/21</a:t>
+              <a:t>9/3/21</a:t>
             </a:fld>
             <a:endParaRPr lang="en-US"/>
           </a:p>
@@ -1972,7 +1972,7 @@
           <a:p>
             <a:fld id="{16F93EB0-79FE-3A48-9677-781C433206CF}" type="datetimeFigureOut">
               <a:rPr lang="en-US" smtClean="0"/>
-              <a:t>8/30/21</a:t>
+              <a:t>9/3/21</a:t>
             </a:fld>
             <a:endParaRPr lang="en-US"/>
           </a:p>
@@ -2085,7 +2085,7 @@
           <a:p>
             <a:fld id="{16F93EB0-79FE-3A48-9677-781C433206CF}" type="datetimeFigureOut">
               <a:rPr lang="en-US" smtClean="0"/>
-              <a:t>8/30/21</a:t>
+              <a:t>9/3/21</a:t>
             </a:fld>
             <a:endParaRPr lang="en-US"/>
           </a:p>
@@ -2398,7 +2398,7 @@
           <a:p>
             <a:fld id="{16F93EB0-79FE-3A48-9677-781C433206CF}" type="datetimeFigureOut">
               <a:rPr lang="en-US" smtClean="0"/>
-              <a:t>8/30/21</a:t>
+              <a:t>9/3/21</a:t>
             </a:fld>
             <a:endParaRPr lang="en-US"/>
           </a:p>
@@ -2687,7 +2687,7 @@
           <a:p>
             <a:fld id="{16F93EB0-79FE-3A48-9677-781C433206CF}" type="datetimeFigureOut">
               <a:rPr lang="en-US" smtClean="0"/>
-              <a:t>8/30/21</a:t>
+              <a:t>9/3/21</a:t>
             </a:fld>
             <a:endParaRPr lang="en-US"/>
           </a:p>
@@ -2930,7 +2930,7 @@
           <a:p>
             <a:fld id="{16F93EB0-79FE-3A48-9677-781C433206CF}" type="datetimeFigureOut">
               <a:rPr lang="en-US" smtClean="0"/>
-              <a:t>8/30/21</a:t>
+              <a:t>9/3/21</a:t>
             </a:fld>
             <a:endParaRPr lang="en-US"/>
           </a:p>
@@ -4477,7 +4477,7 @@
         </p:nvGrpSpPr>
         <p:grpSpPr>
           <a:xfrm>
-            <a:off x="9161120" y="1662234"/>
+            <a:off x="8802614" y="2535199"/>
             <a:ext cx="870425" cy="984175"/>
             <a:chOff x="9818170" y="3088909"/>
             <a:chExt cx="670592" cy="758227"/>
@@ -31092,6 +31092,162 @@
           </a:prstGeom>
         </p:spPr>
       </p:pic>
+      <p:grpSp>
+        <p:nvGrpSpPr>
+          <p:cNvPr id="9" name="Group 8">
+            <a:extLst>
+              <a:ext uri="{FF2B5EF4-FFF2-40B4-BE49-F238E27FC236}">
+                <a16:creationId xmlns:a16="http://schemas.microsoft.com/office/drawing/2014/main" id="{7F634254-3F69-D84D-A252-DFEAFC70E7EF}"/>
+              </a:ext>
+            </a:extLst>
+          </p:cNvPr>
+          <p:cNvGrpSpPr/>
+          <p:nvPr/>
+        </p:nvGrpSpPr>
+        <p:grpSpPr>
+          <a:xfrm>
+            <a:off x="8557341" y="575656"/>
+            <a:ext cx="1302078" cy="1226250"/>
+            <a:chOff x="8669047" y="373287"/>
+            <a:chExt cx="2104010" cy="1981477"/>
+          </a:xfrm>
+        </p:grpSpPr>
+        <p:pic>
+          <p:nvPicPr>
+            <p:cNvPr id="724" name="Picture 723">
+              <a:extLst>
+                <a:ext uri="{FF2B5EF4-FFF2-40B4-BE49-F238E27FC236}">
+                  <a16:creationId xmlns:a16="http://schemas.microsoft.com/office/drawing/2014/main" id="{2E2E304F-0D3B-0047-86E9-1D02F912C242}"/>
+                </a:ext>
+              </a:extLst>
+            </p:cNvPr>
+            <p:cNvPicPr>
+              <a:picLocks noChangeAspect="1"/>
+            </p:cNvPicPr>
+            <p:nvPr/>
+          </p:nvPicPr>
+          <p:blipFill rotWithShape="1">
+            <a:blip r:embed="rId16"/>
+            <a:srcRect r="75948"/>
+            <a:stretch/>
+          </p:blipFill>
+          <p:spPr>
+            <a:xfrm>
+              <a:off x="8874063" y="373287"/>
+              <a:ext cx="1671464" cy="1490814"/>
+            </a:xfrm>
+            <a:prstGeom prst="rect">
+              <a:avLst/>
+            </a:prstGeom>
+          </p:spPr>
+        </p:pic>
+        <p:pic>
+          <p:nvPicPr>
+            <p:cNvPr id="725" name="Picture 724">
+              <a:extLst>
+                <a:ext uri="{FF2B5EF4-FFF2-40B4-BE49-F238E27FC236}">
+                  <a16:creationId xmlns:a16="http://schemas.microsoft.com/office/drawing/2014/main" id="{DFB488F4-5771-864F-A37C-DBD4AF8F2C2F}"/>
+                </a:ext>
+              </a:extLst>
+            </p:cNvPr>
+            <p:cNvPicPr>
+              <a:picLocks noChangeAspect="1"/>
+            </p:cNvPicPr>
+            <p:nvPr/>
+          </p:nvPicPr>
+          <p:blipFill rotWithShape="1">
+            <a:blip r:embed="rId16"/>
+            <a:srcRect l="26201"/>
+            <a:stretch/>
+          </p:blipFill>
+          <p:spPr>
+            <a:xfrm>
+              <a:off x="8669047" y="1743158"/>
+              <a:ext cx="2104010" cy="611606"/>
+            </a:xfrm>
+            <a:prstGeom prst="rect">
+              <a:avLst/>
+            </a:prstGeom>
+          </p:spPr>
+        </p:pic>
+      </p:grpSp>
+      <p:sp>
+        <p:nvSpPr>
+          <p:cNvPr id="731" name="Rectangle 730">
+            <a:extLst>
+              <a:ext uri="{FF2B5EF4-FFF2-40B4-BE49-F238E27FC236}">
+                <a16:creationId xmlns:a16="http://schemas.microsoft.com/office/drawing/2014/main" id="{9495C03A-6ECE-9B49-8E66-C782126CE539}"/>
+              </a:ext>
+            </a:extLst>
+          </p:cNvPr>
+          <p:cNvSpPr/>
+          <p:nvPr/>
+        </p:nvSpPr>
+        <p:spPr>
+          <a:xfrm>
+            <a:off x="8533623" y="498253"/>
+            <a:ext cx="1368208" cy="1368208"/>
+          </a:xfrm>
+          <a:prstGeom prst="rect">
+            <a:avLst/>
+          </a:prstGeom>
+          <a:noFill/>
+        </p:spPr>
+        <p:style>
+          <a:lnRef idx="2">
+            <a:schemeClr val="accent1">
+              <a:shade val="50000"/>
+            </a:schemeClr>
+          </a:lnRef>
+          <a:fillRef idx="1">
+            <a:schemeClr val="accent1"/>
+          </a:fillRef>
+          <a:effectRef idx="0">
+            <a:schemeClr val="accent1"/>
+          </a:effectRef>
+          <a:fontRef idx="minor">
+            <a:schemeClr val="lt1"/>
+          </a:fontRef>
+        </p:style>
+        <p:txBody>
+          <a:bodyPr rtlCol="0" anchor="ctr"/>
+          <a:lstStyle/>
+          <a:p>
+            <a:pPr algn="ctr"/>
+            <a:endParaRPr lang="en-US"/>
+          </a:p>
+        </p:txBody>
+      </p:sp>
+      <p:pic>
+        <p:nvPicPr>
+          <p:cNvPr id="10" name="Picture 9">
+            <a:extLst>
+              <a:ext uri="{FF2B5EF4-FFF2-40B4-BE49-F238E27FC236}">
+                <a16:creationId xmlns:a16="http://schemas.microsoft.com/office/drawing/2014/main" id="{9710CC72-3BC5-1349-B056-53754E12C898}"/>
+              </a:ext>
+            </a:extLst>
+          </p:cNvPr>
+          <p:cNvPicPr>
+            <a:picLocks noChangeAspect="1"/>
+          </p:cNvPicPr>
+          <p:nvPr/>
+        </p:nvPicPr>
+        <p:blipFill>
+          <a:blip r:embed="rId17"/>
+          <a:stretch>
+            <a:fillRect/>
+          </a:stretch>
+        </p:blipFill>
+        <p:spPr>
+          <a:xfrm>
+            <a:off x="16122819" y="6107173"/>
+            <a:ext cx="5308600" cy="5194300"/>
+          </a:xfrm>
+          <a:prstGeom prst="rect">
+            <a:avLst/>
+          </a:prstGeom>
+        </p:spPr>
+      </p:pic>
     </p:spTree>
     <p:extLst>
       <p:ext uri="{BB962C8B-B14F-4D97-AF65-F5344CB8AC3E}">

</xml_diff>